<commit_message>
docs: integrar evidencias, diagramas de 6 CUs y unificar entregables en las 4 variantes
- Integrar diagramas PowerDesigner (OOm) y modelos PNG de los 6 Casos de Uso (CU-01 a CU-06) en TI.1.1, TI.1.2, TI.1.3 y TI.1.4.
- Unificar documentos ERS, ECUD, manuales técnicos y presentaciones PPTX sin marcadores pendientes.
- Actualizar plantillas maestras en vault/03-deliverables/templates/ (PLANTILLA_ECUD.docx y PLANTILLA_PRESENTACION.pptx).
- Actualizar scripts/generate_docs.py para reproducibilidad total con stacks oficiales (.NET 10, Payara 7, Java 11/17) y autores formales Murillo/Viche.
- Homogeneizar manuales técnicos y evidencias fotográficas en vault/06-projects/ti-1-4-rest-dotnet/.
- Validar entrega completa con scripts/validate_deliverables.py (16/16 PASS, 0 errores).
</commit_message>
<xml_diff>
--- a/TI.1.2. PAO202651_SOAP_DOTNET_SINBDD_NRC36884_GR09/05. DOCUMENTACION/CONVUNI_SOAP_DOTNET_GR09.pptx
+++ b/TI.1.2. PAO202651_SOAP_DOTNET_SINBDD_NRC36884_GR09/05. DOCUMENTACION/CONVUNI_SOAP_DOTNET_GR09.pptx
@@ -19362,18 +19362,19 @@
           </a:p>
         </p:txBody>
       </p:sp>
-      <p:sp>
-        <p:nvSpPr>
-          <p:cNvPr id="2" name="CAPTURA PENDIENTE - Controlador y cliente de servicio">
-            <a:extLst>
-              <a:ext uri="{FF2B5EF4-FFF2-40B4-BE49-F238E27FC236}">
-                <a16:creationId xmlns:a16="http://schemas.microsoft.com/office/drawing/2014/main" id="{7DD048F7-291C-4466-917F-C53A70400149}"/>
-              </a:ext>
-            </a:extLst>
-          </p:cNvPr>
-          <p:cNvSpPr/>
+      <p:pic>
+        <p:nvPicPr>
+          <p:cNvPr id="242" name="image70.png"/>
+          <p:cNvPicPr/>
           <p:nvPr/>
-        </p:nvSpPr>
+        </p:nvPicPr>
+        <p:blipFill>
+          <a:blip r:embed="rId3"/>
+          <a:srcRect/>
+          <a:stretch>
+            <a:fillRect/>
+          </a:stretch>
+        </p:blipFill>
         <p:spPr>
           <a:xfrm>
             <a:off x="4100618" y="4064763"/>
@@ -19382,80 +19383,26 @@
           <a:prstGeom prst="rect">
             <a:avLst/>
           </a:prstGeom>
-          <a:solidFill>
-            <a:srgbClr val="FFFFFF"/>
-          </a:solidFill>
-          <a:ln w="15875">
+          <a:ln w="12700">
             <a:solidFill>
-              <a:srgbClr val="D9D9D9"/>
+              <a:srgbClr val="CCCCCC"/>
             </a:solidFill>
           </a:ln>
         </p:spPr>
-        <p:style>
-          <a:lnRef idx="2">
-            <a:schemeClr val="accent1">
-              <a:shade val="50000"/>
-            </a:schemeClr>
-          </a:lnRef>
-          <a:fillRef idx="1">
-            <a:schemeClr val="accent1"/>
-          </a:fillRef>
-          <a:effectRef idx="0">
-            <a:schemeClr val="accent1"/>
-          </a:effectRef>
-          <a:fontRef idx="minor">
-            <a:schemeClr val="lt1"/>
-          </a:fontRef>
-        </p:style>
-        <p:txBody>
-          <a:bodyPr wrap="square" lIns="76200" tIns="38100" rIns="76200" bIns="38100" rtlCol="0" anchor="ctr">
-            <a:noAutofit/>
-          </a:bodyPr>
-          <a:lstStyle/>
-          <a:p>
-            <a:pPr algn="ctr"/>
-            <a:r>
-              <a:rPr lang="es-ES" sz="900" i="1">
-                <a:solidFill>
-                  <a:srgbClr val="666666"/>
-                </a:solidFill>
-                <a:latin typeface="Arial" panose="020B0604020202020204" pitchFamily="34" charset="0"/>
-              </a:rPr>
-              <a:t>CAPTURA PENDIENTE</a:t>
-            </a:r>
-          </a:p>
-          <a:p>
-            <a:pPr algn="ctr"/>
-            <a:r>
-              <a:rPr lang="es-ES" sz="900" i="1">
-                <a:solidFill>
-                  <a:srgbClr val="666666"/>
-                </a:solidFill>
-                <a:latin typeface="Arial" panose="020B0604020202020204" pitchFamily="34" charset="0"/>
-              </a:rPr>
-              <a:t>Controlador y cliente de servicio</a:t>
-            </a:r>
-            <a:endParaRPr lang="en-US" sz="900" i="1">
-              <a:solidFill>
-                <a:srgbClr val="666666"/>
-              </a:solidFill>
-              <a:latin typeface="Arial" panose="020B0604020202020204" pitchFamily="34" charset="0"/>
-            </a:endParaRPr>
-          </a:p>
-        </p:txBody>
-      </p:sp>
-      <p:sp>
-        <p:nvSpPr>
-          <p:cNvPr id="4" name="CAPTURA PENDIENTE - Modelo de solicitud de conversión">
-            <a:extLst>
-              <a:ext uri="{FF2B5EF4-FFF2-40B4-BE49-F238E27FC236}">
-                <a16:creationId xmlns:a16="http://schemas.microsoft.com/office/drawing/2014/main" id="{BE1FDCDF-BB08-4024-ACC0-08D4758E0B68}"/>
-              </a:ext>
-            </a:extLst>
-          </p:cNvPr>
-          <p:cNvSpPr/>
+      </p:pic>
+      <p:pic>
+        <p:nvPicPr>
+          <p:cNvPr id="243" name="image71.png"/>
+          <p:cNvPicPr/>
           <p:nvPr/>
-        </p:nvSpPr>
+        </p:nvPicPr>
+        <p:blipFill>
+          <a:blip r:embed="rId4"/>
+          <a:srcRect/>
+          <a:stretch>
+            <a:fillRect/>
+          </a:stretch>
+        </p:blipFill>
         <p:spPr>
           <a:xfrm>
             <a:off x="811793" y="4064763"/>
@@ -19464,68 +19411,13 @@
           <a:prstGeom prst="rect">
             <a:avLst/>
           </a:prstGeom>
-          <a:solidFill>
-            <a:srgbClr val="FFFFFF"/>
-          </a:solidFill>
-          <a:ln w="15875">
+          <a:ln w="12700">
             <a:solidFill>
-              <a:srgbClr val="D9D9D9"/>
+              <a:srgbClr val="CCCCCC"/>
             </a:solidFill>
           </a:ln>
         </p:spPr>
-        <p:style>
-          <a:lnRef idx="2">
-            <a:schemeClr val="accent1">
-              <a:shade val="50000"/>
-            </a:schemeClr>
-          </a:lnRef>
-          <a:fillRef idx="1">
-            <a:schemeClr val="accent1"/>
-          </a:fillRef>
-          <a:effectRef idx="0">
-            <a:schemeClr val="accent1"/>
-          </a:effectRef>
-          <a:fontRef idx="minor">
-            <a:schemeClr val="lt1"/>
-          </a:fontRef>
-        </p:style>
-        <p:txBody>
-          <a:bodyPr wrap="square" lIns="76200" tIns="38100" rIns="76200" bIns="38100" rtlCol="0" anchor="ctr">
-            <a:noAutofit/>
-          </a:bodyPr>
-          <a:lstStyle/>
-          <a:p>
-            <a:pPr algn="ctr"/>
-            <a:r>
-              <a:rPr lang="es-ES" sz="900" i="1">
-                <a:solidFill>
-                  <a:srgbClr val="666666"/>
-                </a:solidFill>
-                <a:latin typeface="Arial" panose="020B0604020202020204" pitchFamily="34" charset="0"/>
-              </a:rPr>
-              <a:t>CAPTURA PENDIENTE</a:t>
-            </a:r>
-          </a:p>
-          <a:p>
-            <a:pPr algn="ctr"/>
-            <a:r>
-              <a:rPr lang="es-ES" sz="900" i="1">
-                <a:solidFill>
-                  <a:srgbClr val="666666"/>
-                </a:solidFill>
-                <a:latin typeface="Arial" panose="020B0604020202020204" pitchFamily="34" charset="0"/>
-              </a:rPr>
-              <a:t>Modelo de solicitud de conversión</a:t>
-            </a:r>
-            <a:endParaRPr lang="en-US" sz="900" i="1">
-              <a:solidFill>
-                <a:srgbClr val="666666"/>
-              </a:solidFill>
-              <a:latin typeface="Arial" panose="020B0604020202020204" pitchFamily="34" charset="0"/>
-            </a:endParaRPr>
-          </a:p>
-        </p:txBody>
-      </p:sp>
+      </p:pic>
     </p:spTree>
   </p:cSld>
   <p:clrMapOvr>
@@ -20151,18 +20043,19 @@
           </a:p>
         </p:txBody>
       </p:sp>
-      <p:sp>
-        <p:nvSpPr>
-          <p:cNvPr id="2" name="CAPTURA PENDIENTE - Menú y vista del cliente de consola">
-            <a:extLst>
-              <a:ext uri="{FF2B5EF4-FFF2-40B4-BE49-F238E27FC236}">
-                <a16:creationId xmlns:a16="http://schemas.microsoft.com/office/drawing/2014/main" id="{86A93331-0F14-4AEA-961B-40B7F4D43301}"/>
-              </a:ext>
-            </a:extLst>
-          </p:cNvPr>
-          <p:cNvSpPr/>
+      <p:pic>
+        <p:nvPicPr>
+          <p:cNvPr id="251" name="image72.png"/>
+          <p:cNvPicPr/>
           <p:nvPr/>
-        </p:nvSpPr>
+        </p:nvPicPr>
+        <p:blipFill>
+          <a:blip r:embed="rId3"/>
+          <a:srcRect/>
+          <a:stretch>
+            <a:fillRect/>
+          </a:stretch>
+        </p:blipFill>
         <p:spPr>
           <a:xfrm>
             <a:off x="4361215" y="2617179"/>
@@ -20171,68 +20064,13 @@
           <a:prstGeom prst="rect">
             <a:avLst/>
           </a:prstGeom>
-          <a:solidFill>
-            <a:srgbClr val="FFFFFF"/>
-          </a:solidFill>
-          <a:ln w="15875">
+          <a:ln w="12700">
             <a:solidFill>
-              <a:srgbClr val="D9D9D9"/>
+              <a:srgbClr val="CCCCCC"/>
             </a:solidFill>
           </a:ln>
         </p:spPr>
-        <p:style>
-          <a:lnRef idx="2">
-            <a:schemeClr val="accent1">
-              <a:shade val="50000"/>
-            </a:schemeClr>
-          </a:lnRef>
-          <a:fillRef idx="1">
-            <a:schemeClr val="accent1"/>
-          </a:fillRef>
-          <a:effectRef idx="0">
-            <a:schemeClr val="accent1"/>
-          </a:effectRef>
-          <a:fontRef idx="minor">
-            <a:schemeClr val="lt1"/>
-          </a:fontRef>
-        </p:style>
-        <p:txBody>
-          <a:bodyPr wrap="square" lIns="76200" tIns="38100" rIns="76200" bIns="38100" rtlCol="0" anchor="ctr">
-            <a:noAutofit/>
-          </a:bodyPr>
-          <a:lstStyle/>
-          <a:p>
-            <a:pPr algn="ctr"/>
-            <a:r>
-              <a:rPr lang="es-ES" sz="900" i="1">
-                <a:solidFill>
-                  <a:srgbClr val="666666"/>
-                </a:solidFill>
-                <a:latin typeface="Arial" panose="020B0604020202020204" pitchFamily="34" charset="0"/>
-              </a:rPr>
-              <a:t>CAPTURA PENDIENTE</a:t>
-            </a:r>
-          </a:p>
-          <a:p>
-            <a:pPr algn="ctr"/>
-            <a:r>
-              <a:rPr lang="es-ES" sz="900" i="1">
-                <a:solidFill>
-                  <a:srgbClr val="666666"/>
-                </a:solidFill>
-                <a:latin typeface="Arial" panose="020B0604020202020204" pitchFamily="34" charset="0"/>
-              </a:rPr>
-              <a:t>Menú y vista del cliente de consola</a:t>
-            </a:r>
-            <a:endParaRPr lang="en-US" sz="900" i="1">
-              <a:solidFill>
-                <a:srgbClr val="666666"/>
-              </a:solidFill>
-              <a:latin typeface="Arial" panose="020B0604020202020204" pitchFamily="34" charset="0"/>
-            </a:endParaRPr>
-          </a:p>
-        </p:txBody>
-      </p:sp>
+      </p:pic>
     </p:spTree>
   </p:cSld>
   <p:clrMapOvr>
@@ -20834,18 +20672,19 @@
           </a:p>
         </p:txBody>
       </p:sp>
-      <p:sp>
-        <p:nvSpPr>
-          <p:cNvPr id="2" name="CAPTURA PENDIENTE - Resultado de conversión">
-            <a:extLst>
-              <a:ext uri="{FF2B5EF4-FFF2-40B4-BE49-F238E27FC236}">
-                <a16:creationId xmlns:a16="http://schemas.microsoft.com/office/drawing/2014/main" id="{708B9276-A510-45E6-9B14-51584D3088AA}"/>
-              </a:ext>
-            </a:extLst>
-          </p:cNvPr>
-          <p:cNvSpPr/>
+      <p:pic>
+        <p:nvPicPr>
+          <p:cNvPr id="259" name="image116.png"/>
+          <p:cNvPicPr/>
           <p:nvPr/>
-        </p:nvSpPr>
+        </p:nvPicPr>
+        <p:blipFill>
+          <a:blip r:embed="rId3"/>
+          <a:srcRect/>
+          <a:stretch>
+            <a:fillRect/>
+          </a:stretch>
+        </p:blipFill>
         <p:spPr>
           <a:xfrm>
             <a:off x="6143877" y="3004463"/>
@@ -20854,80 +20693,26 @@
           <a:prstGeom prst="rect">
             <a:avLst/>
           </a:prstGeom>
-          <a:solidFill>
-            <a:srgbClr val="FFFFFF"/>
-          </a:solidFill>
-          <a:ln w="15875">
+          <a:ln w="12700">
             <a:solidFill>
-              <a:srgbClr val="D9D9D9"/>
+              <a:srgbClr val="CCCCCC"/>
             </a:solidFill>
           </a:ln>
         </p:spPr>
-        <p:style>
-          <a:lnRef idx="2">
-            <a:schemeClr val="accent1">
-              <a:shade val="50000"/>
-            </a:schemeClr>
-          </a:lnRef>
-          <a:fillRef idx="1">
-            <a:schemeClr val="accent1"/>
-          </a:fillRef>
-          <a:effectRef idx="0">
-            <a:schemeClr val="accent1"/>
-          </a:effectRef>
-          <a:fontRef idx="minor">
-            <a:schemeClr val="lt1"/>
-          </a:fontRef>
-        </p:style>
-        <p:txBody>
-          <a:bodyPr wrap="square" lIns="76200" tIns="38100" rIns="76200" bIns="38100" rtlCol="0" anchor="ctr">
-            <a:noAutofit/>
-          </a:bodyPr>
-          <a:lstStyle/>
-          <a:p>
-            <a:pPr algn="ctr"/>
-            <a:r>
-              <a:rPr lang="es-ES" sz="900" i="1">
-                <a:solidFill>
-                  <a:srgbClr val="666666"/>
-                </a:solidFill>
-                <a:latin typeface="Arial" panose="020B0604020202020204" pitchFamily="34" charset="0"/>
-              </a:rPr>
-              <a:t>CAPTURA PENDIENTE</a:t>
-            </a:r>
-          </a:p>
-          <a:p>
-            <a:pPr algn="ctr"/>
-            <a:r>
-              <a:rPr lang="es-ES" sz="900" i="1">
-                <a:solidFill>
-                  <a:srgbClr val="666666"/>
-                </a:solidFill>
-                <a:latin typeface="Arial" panose="020B0604020202020204" pitchFamily="34" charset="0"/>
-              </a:rPr>
-              <a:t>Resultado de conversión</a:t>
-            </a:r>
-            <a:endParaRPr lang="en-US" sz="900" i="1">
-              <a:solidFill>
-                <a:srgbClr val="666666"/>
-              </a:solidFill>
-              <a:latin typeface="Arial" panose="020B0604020202020204" pitchFamily="34" charset="0"/>
-            </a:endParaRPr>
-          </a:p>
-        </p:txBody>
-      </p:sp>
-      <p:sp>
-        <p:nvSpPr>
-          <p:cNvPr id="3" name="CAPTURA PENDIENTE - Selección de magnitud y unidades">
-            <a:extLst>
-              <a:ext uri="{FF2B5EF4-FFF2-40B4-BE49-F238E27FC236}">
-                <a16:creationId xmlns:a16="http://schemas.microsoft.com/office/drawing/2014/main" id="{AD0D4F79-D159-4DE7-A355-9CDF12FB1E7D}"/>
-              </a:ext>
-            </a:extLst>
-          </p:cNvPr>
-          <p:cNvSpPr/>
+      </p:pic>
+      <p:pic>
+        <p:nvPicPr>
+          <p:cNvPr id="260" name="image117.png"/>
+          <p:cNvPicPr/>
           <p:nvPr/>
-        </p:nvSpPr>
+        </p:nvPicPr>
+        <p:blipFill>
+          <a:blip r:embed="rId4"/>
+          <a:srcRect/>
+          <a:stretch>
+            <a:fillRect/>
+          </a:stretch>
+        </p:blipFill>
         <p:spPr>
           <a:xfrm>
             <a:off x="3227647" y="3004463"/>
@@ -20936,80 +20721,26 @@
           <a:prstGeom prst="rect">
             <a:avLst/>
           </a:prstGeom>
-          <a:solidFill>
-            <a:srgbClr val="FFFFFF"/>
-          </a:solidFill>
-          <a:ln w="15875">
+          <a:ln w="12700">
             <a:solidFill>
-              <a:srgbClr val="D9D9D9"/>
+              <a:srgbClr val="CCCCCC"/>
             </a:solidFill>
           </a:ln>
         </p:spPr>
-        <p:style>
-          <a:lnRef idx="2">
-            <a:schemeClr val="accent1">
-              <a:shade val="50000"/>
-            </a:schemeClr>
-          </a:lnRef>
-          <a:fillRef idx="1">
-            <a:schemeClr val="accent1"/>
-          </a:fillRef>
-          <a:effectRef idx="0">
-            <a:schemeClr val="accent1"/>
-          </a:effectRef>
-          <a:fontRef idx="minor">
-            <a:schemeClr val="lt1"/>
-          </a:fontRef>
-        </p:style>
-        <p:txBody>
-          <a:bodyPr wrap="square" lIns="76200" tIns="38100" rIns="76200" bIns="38100" rtlCol="0" anchor="ctr">
-            <a:noAutofit/>
-          </a:bodyPr>
-          <a:lstStyle/>
-          <a:p>
-            <a:pPr algn="ctr"/>
-            <a:r>
-              <a:rPr lang="es-ES" sz="900" i="1">
-                <a:solidFill>
-                  <a:srgbClr val="666666"/>
-                </a:solidFill>
-                <a:latin typeface="Arial" panose="020B0604020202020204" pitchFamily="34" charset="0"/>
-              </a:rPr>
-              <a:t>CAPTURA PENDIENTE</a:t>
-            </a:r>
-          </a:p>
-          <a:p>
-            <a:pPr algn="ctr"/>
-            <a:r>
-              <a:rPr lang="es-ES" sz="900" i="1">
-                <a:solidFill>
-                  <a:srgbClr val="666666"/>
-                </a:solidFill>
-                <a:latin typeface="Arial" panose="020B0604020202020204" pitchFamily="34" charset="0"/>
-              </a:rPr>
-              <a:t>Selección de magnitud y unidades</a:t>
-            </a:r>
-            <a:endParaRPr lang="en-US" sz="900" i="1">
-              <a:solidFill>
-                <a:srgbClr val="666666"/>
-              </a:solidFill>
-              <a:latin typeface="Arial" panose="020B0604020202020204" pitchFamily="34" charset="0"/>
-            </a:endParaRPr>
-          </a:p>
-        </p:txBody>
-      </p:sp>
-      <p:sp>
-        <p:nvSpPr>
-          <p:cNvPr id="4" name="CAPTURA PENDIENTE - Autenticación correcta">
-            <a:extLst>
-              <a:ext uri="{FF2B5EF4-FFF2-40B4-BE49-F238E27FC236}">
-                <a16:creationId xmlns:a16="http://schemas.microsoft.com/office/drawing/2014/main" id="{7F99F7C5-D9BE-4E6B-AE75-5BFAABFDAA28}"/>
-              </a:ext>
-            </a:extLst>
-          </p:cNvPr>
-          <p:cNvSpPr/>
+      </p:pic>
+      <p:pic>
+        <p:nvPicPr>
+          <p:cNvPr id="261" name="image118.png"/>
+          <p:cNvPicPr/>
           <p:nvPr/>
-        </p:nvSpPr>
+        </p:nvPicPr>
+        <p:blipFill>
+          <a:blip r:embed="rId5"/>
+          <a:srcRect/>
+          <a:stretch>
+            <a:fillRect/>
+          </a:stretch>
+        </p:blipFill>
         <p:spPr>
           <a:xfrm>
             <a:off x="311657" y="3004463"/>
@@ -21018,74 +20749,26 @@
           <a:prstGeom prst="rect">
             <a:avLst/>
           </a:prstGeom>
-          <a:solidFill>
-            <a:srgbClr val="FFFFFF"/>
-          </a:solidFill>
-          <a:ln w="15875">
+          <a:ln w="12700">
             <a:solidFill>
-              <a:srgbClr val="D9D9D9"/>
+              <a:srgbClr val="CCCCCC"/>
             </a:solidFill>
           </a:ln>
         </p:spPr>
-        <p:style>
-          <a:lnRef idx="2">
-            <a:schemeClr val="accent1">
-              <a:shade val="50000"/>
-            </a:schemeClr>
-          </a:lnRef>
-          <a:fillRef idx="1">
-            <a:schemeClr val="accent1"/>
-          </a:fillRef>
-          <a:effectRef idx="0">
-            <a:schemeClr val="accent1"/>
-          </a:effectRef>
-          <a:fontRef idx="minor">
-            <a:schemeClr val="lt1"/>
-          </a:fontRef>
-        </p:style>
-        <p:txBody>
-          <a:bodyPr wrap="square" lIns="76200" tIns="38100" rIns="76200" bIns="38100" rtlCol="0" anchor="ctr">
-            <a:noAutofit/>
-          </a:bodyPr>
-          <a:lstStyle/>
-          <a:p>
-            <a:pPr algn="ctr"/>
-            <a:r>
-              <a:rPr lang="en-US" sz="900" i="1">
-                <a:solidFill>
-                  <a:srgbClr val="666666"/>
-                </a:solidFill>
-                <a:latin typeface="Arial" panose="020B0604020202020204" pitchFamily="34" charset="0"/>
-              </a:rPr>
-              <a:t>CAPTURA PENDIENTE</a:t>
-            </a:r>
-          </a:p>
-          <a:p>
-            <a:pPr algn="ctr"/>
-            <a:r>
-              <a:rPr lang="en-US" sz="900" i="1">
-                <a:solidFill>
-                  <a:srgbClr val="666666"/>
-                </a:solidFill>
-                <a:latin typeface="Arial" panose="020B0604020202020204" pitchFamily="34" charset="0"/>
-              </a:rPr>
-              <a:t>Autenticación correcta</a:t>
-            </a:r>
-          </a:p>
-        </p:txBody>
-      </p:sp>
-      <p:sp>
-        <p:nvSpPr>
-          <p:cNvPr id="5" name="CAPTURA PENDIENTE - Inicio del cliente">
-            <a:extLst>
-              <a:ext uri="{FF2B5EF4-FFF2-40B4-BE49-F238E27FC236}">
-                <a16:creationId xmlns:a16="http://schemas.microsoft.com/office/drawing/2014/main" id="{8E2476A0-8191-4A53-A3DE-FADF4D8205EF}"/>
-              </a:ext>
-            </a:extLst>
-          </p:cNvPr>
-          <p:cNvSpPr/>
+      </p:pic>
+      <p:pic>
+        <p:nvPicPr>
+          <p:cNvPr id="262" name="image119.png"/>
+          <p:cNvPicPr/>
           <p:nvPr/>
-        </p:nvSpPr>
+        </p:nvPicPr>
+        <p:blipFill>
+          <a:blip r:embed="rId6"/>
+          <a:srcRect/>
+          <a:stretch>
+            <a:fillRect/>
+          </a:stretch>
+        </p:blipFill>
         <p:spPr>
           <a:xfrm>
             <a:off x="3227647" y="1933668"/>
@@ -21094,62 +20777,13 @@
           <a:prstGeom prst="rect">
             <a:avLst/>
           </a:prstGeom>
-          <a:solidFill>
-            <a:srgbClr val="FFFFFF"/>
-          </a:solidFill>
-          <a:ln w="15875">
+          <a:ln w="12700">
             <a:solidFill>
-              <a:srgbClr val="D9D9D9"/>
+              <a:srgbClr val="CCCCCC"/>
             </a:solidFill>
           </a:ln>
         </p:spPr>
-        <p:style>
-          <a:lnRef idx="2">
-            <a:schemeClr val="accent1">
-              <a:shade val="50000"/>
-            </a:schemeClr>
-          </a:lnRef>
-          <a:fillRef idx="1">
-            <a:schemeClr val="accent1"/>
-          </a:fillRef>
-          <a:effectRef idx="0">
-            <a:schemeClr val="accent1"/>
-          </a:effectRef>
-          <a:fontRef idx="minor">
-            <a:schemeClr val="lt1"/>
-          </a:fontRef>
-        </p:style>
-        <p:txBody>
-          <a:bodyPr wrap="square" lIns="76200" tIns="38100" rIns="76200" bIns="38100" rtlCol="0" anchor="ctr">
-            <a:noAutofit/>
-          </a:bodyPr>
-          <a:lstStyle/>
-          <a:p>
-            <a:pPr algn="ctr"/>
-            <a:r>
-              <a:rPr lang="en-US" sz="900" i="1">
-                <a:solidFill>
-                  <a:srgbClr val="666666"/>
-                </a:solidFill>
-                <a:latin typeface="Arial" panose="020B0604020202020204" pitchFamily="34" charset="0"/>
-              </a:rPr>
-              <a:t>CAPTURA PENDIENTE</a:t>
-            </a:r>
-          </a:p>
-          <a:p>
-            <a:pPr algn="ctr"/>
-            <a:r>
-              <a:rPr lang="en-US" sz="900" i="1">
-                <a:solidFill>
-                  <a:srgbClr val="666666"/>
-                </a:solidFill>
-                <a:latin typeface="Arial" panose="020B0604020202020204" pitchFamily="34" charset="0"/>
-              </a:rPr>
-              <a:t>Inicio del cliente</a:t>
-            </a:r>
-          </a:p>
-        </p:txBody>
-      </p:sp>
+      </p:pic>
     </p:spTree>
   </p:cSld>
   <p:clrMapOvr>
@@ -21796,18 +21430,19 @@
           </a:p>
         </p:txBody>
       </p:sp>
-      <p:sp>
-        <p:nvSpPr>
-          <p:cNvPr id="2" name="CAPTURA PENDIENTE - Creación del proyecto de escritorio .NET / C#">
-            <a:extLst>
-              <a:ext uri="{FF2B5EF4-FFF2-40B4-BE49-F238E27FC236}">
-                <a16:creationId xmlns:a16="http://schemas.microsoft.com/office/drawing/2014/main" id="{D28BE577-97A7-4289-87EA-2CB12471E21C}"/>
-              </a:ext>
-            </a:extLst>
-          </p:cNvPr>
-          <p:cNvSpPr/>
+      <p:pic>
+        <p:nvPicPr>
+          <p:cNvPr id="270" name="image77.png"/>
+          <p:cNvPicPr/>
           <p:nvPr/>
-        </p:nvSpPr>
+        </p:nvPicPr>
+        <p:blipFill>
+          <a:blip r:embed="rId3"/>
+          <a:srcRect/>
+          <a:stretch>
+            <a:fillRect/>
+          </a:stretch>
+        </p:blipFill>
         <p:spPr>
           <a:xfrm>
             <a:off x="2544819" y="3270983"/>
@@ -21816,68 +21451,13 @@
           <a:prstGeom prst="rect">
             <a:avLst/>
           </a:prstGeom>
-          <a:solidFill>
-            <a:srgbClr val="FFFFFF"/>
-          </a:solidFill>
-          <a:ln w="15875">
+          <a:ln w="12700">
             <a:solidFill>
-              <a:srgbClr val="D9D9D9"/>
+              <a:srgbClr val="CCCCCC"/>
             </a:solidFill>
           </a:ln>
         </p:spPr>
-        <p:style>
-          <a:lnRef idx="2">
-            <a:schemeClr val="accent1">
-              <a:shade val="50000"/>
-            </a:schemeClr>
-          </a:lnRef>
-          <a:fillRef idx="1">
-            <a:schemeClr val="accent1"/>
-          </a:fillRef>
-          <a:effectRef idx="0">
-            <a:schemeClr val="accent1"/>
-          </a:effectRef>
-          <a:fontRef idx="minor">
-            <a:schemeClr val="lt1"/>
-          </a:fontRef>
-        </p:style>
-        <p:txBody>
-          <a:bodyPr wrap="square" lIns="76200" tIns="38100" rIns="76200" bIns="38100" rtlCol="0" anchor="ctr">
-            <a:noAutofit/>
-          </a:bodyPr>
-          <a:lstStyle/>
-          <a:p>
-            <a:pPr algn="ctr"/>
-            <a:r>
-              <a:rPr lang="es-ES" sz="900" i="1">
-                <a:solidFill>
-                  <a:srgbClr val="666666"/>
-                </a:solidFill>
-                <a:latin typeface="Arial" panose="020B0604020202020204" pitchFamily="34" charset="0"/>
-              </a:rPr>
-              <a:t>CAPTURA PENDIENTE</a:t>
-            </a:r>
-          </a:p>
-          <a:p>
-            <a:pPr algn="ctr"/>
-            <a:r>
-              <a:rPr lang="es-ES" sz="900" i="1">
-                <a:solidFill>
-                  <a:srgbClr val="666666"/>
-                </a:solidFill>
-                <a:latin typeface="Arial" panose="020B0604020202020204" pitchFamily="34" charset="0"/>
-              </a:rPr>
-              <a:t>Creación del proyecto de escritorio .NET / C#</a:t>
-            </a:r>
-            <a:endParaRPr lang="en-US" sz="900" i="1">
-              <a:solidFill>
-                <a:srgbClr val="666666"/>
-              </a:solidFill>
-              <a:latin typeface="Arial" panose="020B0604020202020204" pitchFamily="34" charset="0"/>
-            </a:endParaRPr>
-          </a:p>
-        </p:txBody>
-      </p:sp>
+      </p:pic>
     </p:spTree>
   </p:cSld>
   <p:clrMapOvr>
@@ -22580,18 +22160,19 @@
           </a:p>
         </p:txBody>
       </p:sp>
-      <p:sp>
-        <p:nvSpPr>
-          <p:cNvPr id="2" name="CAPTURA PENDIENTE - Clases del cliente de escritorio">
-            <a:extLst>
-              <a:ext uri="{FF2B5EF4-FFF2-40B4-BE49-F238E27FC236}">
-                <a16:creationId xmlns:a16="http://schemas.microsoft.com/office/drawing/2014/main" id="{FC04A46C-F8FC-4B32-89E4-37F1F61238A7}"/>
-              </a:ext>
-            </a:extLst>
-          </p:cNvPr>
-          <p:cNvSpPr/>
+      <p:pic>
+        <p:nvPicPr>
+          <p:cNvPr id="303" name="image78.png"/>
+          <p:cNvPicPr/>
           <p:nvPr/>
-        </p:nvSpPr>
+        </p:nvPicPr>
+        <p:blipFill>
+          <a:blip r:embed="rId3"/>
+          <a:srcRect/>
+          <a:stretch>
+            <a:fillRect/>
+          </a:stretch>
+        </p:blipFill>
         <p:spPr>
           <a:xfrm>
             <a:off x="2474259" y="4377212"/>
@@ -22600,80 +22181,26 @@
           <a:prstGeom prst="rect">
             <a:avLst/>
           </a:prstGeom>
-          <a:solidFill>
-            <a:srgbClr val="FFFFFF"/>
-          </a:solidFill>
-          <a:ln w="15875">
+          <a:ln w="12700">
             <a:solidFill>
-              <a:srgbClr val="D9D9D9"/>
+              <a:srgbClr val="CCCCCC"/>
             </a:solidFill>
           </a:ln>
         </p:spPr>
-        <p:style>
-          <a:lnRef idx="2">
-            <a:schemeClr val="accent1">
-              <a:shade val="50000"/>
-            </a:schemeClr>
-          </a:lnRef>
-          <a:fillRef idx="1">
-            <a:schemeClr val="accent1"/>
-          </a:fillRef>
-          <a:effectRef idx="0">
-            <a:schemeClr val="accent1"/>
-          </a:effectRef>
-          <a:fontRef idx="minor">
-            <a:schemeClr val="lt1"/>
-          </a:fontRef>
-        </p:style>
-        <p:txBody>
-          <a:bodyPr wrap="square" lIns="76200" tIns="38100" rIns="76200" bIns="38100" rtlCol="0" anchor="ctr">
-            <a:noAutofit/>
-          </a:bodyPr>
-          <a:lstStyle/>
-          <a:p>
-            <a:pPr algn="ctr"/>
-            <a:r>
-              <a:rPr lang="es-ES" sz="900" i="1">
-                <a:solidFill>
-                  <a:srgbClr val="666666"/>
-                </a:solidFill>
-                <a:latin typeface="Arial" panose="020B0604020202020204" pitchFamily="34" charset="0"/>
-              </a:rPr>
-              <a:t>CAPTURA PENDIENTE</a:t>
-            </a:r>
-          </a:p>
-          <a:p>
-            <a:pPr algn="ctr"/>
-            <a:r>
-              <a:rPr lang="es-ES" sz="900" i="1">
-                <a:solidFill>
-                  <a:srgbClr val="666666"/>
-                </a:solidFill>
-                <a:latin typeface="Arial" panose="020B0604020202020204" pitchFamily="34" charset="0"/>
-              </a:rPr>
-              <a:t>Clases del cliente de escritorio</a:t>
-            </a:r>
-            <a:endParaRPr lang="en-US" sz="900" i="1">
-              <a:solidFill>
-                <a:srgbClr val="666666"/>
-              </a:solidFill>
-              <a:latin typeface="Arial" panose="020B0604020202020204" pitchFamily="34" charset="0"/>
-            </a:endParaRPr>
-          </a:p>
-        </p:txBody>
-      </p:sp>
-      <p:sp>
-        <p:nvSpPr>
-          <p:cNvPr id="3" name="CAPTURA PENDIENTE - Código de controlador">
-            <a:extLst>
-              <a:ext uri="{FF2B5EF4-FFF2-40B4-BE49-F238E27FC236}">
-                <a16:creationId xmlns:a16="http://schemas.microsoft.com/office/drawing/2014/main" id="{8D27FDBE-3262-425D-901F-736C75C67653}"/>
-              </a:ext>
-            </a:extLst>
-          </p:cNvPr>
-          <p:cNvSpPr/>
+      </p:pic>
+      <p:pic>
+        <p:nvPicPr>
+          <p:cNvPr id="304" name="image79.png"/>
+          <p:cNvPicPr/>
           <p:nvPr/>
-        </p:nvSpPr>
+        </p:nvPicPr>
+        <p:blipFill>
+          <a:blip r:embed="rId4"/>
+          <a:srcRect/>
+          <a:stretch>
+            <a:fillRect/>
+          </a:stretch>
+        </p:blipFill>
         <p:spPr>
           <a:xfrm>
             <a:off x="5925023" y="3893361"/>
@@ -22682,80 +22209,26 @@
           <a:prstGeom prst="rect">
             <a:avLst/>
           </a:prstGeom>
-          <a:solidFill>
-            <a:srgbClr val="FFFFFF"/>
-          </a:solidFill>
-          <a:ln w="15875">
+          <a:ln w="12700">
             <a:solidFill>
-              <a:srgbClr val="D9D9D9"/>
+              <a:srgbClr val="CCCCCC"/>
             </a:solidFill>
           </a:ln>
         </p:spPr>
-        <p:style>
-          <a:lnRef idx="2">
-            <a:schemeClr val="accent1">
-              <a:shade val="50000"/>
-            </a:schemeClr>
-          </a:lnRef>
-          <a:fillRef idx="1">
-            <a:schemeClr val="accent1"/>
-          </a:fillRef>
-          <a:effectRef idx="0">
-            <a:schemeClr val="accent1"/>
-          </a:effectRef>
-          <a:fontRef idx="minor">
-            <a:schemeClr val="lt1"/>
-          </a:fontRef>
-        </p:style>
-        <p:txBody>
-          <a:bodyPr wrap="square" lIns="76200" tIns="38100" rIns="76200" bIns="38100" rtlCol="0" anchor="ctr">
-            <a:noAutofit/>
-          </a:bodyPr>
-          <a:lstStyle/>
-          <a:p>
-            <a:pPr algn="ctr"/>
-            <a:r>
-              <a:rPr lang="pt-BR" sz="900" i="1">
-                <a:solidFill>
-                  <a:srgbClr val="666666"/>
-                </a:solidFill>
-                <a:latin typeface="Arial" panose="020B0604020202020204" pitchFamily="34" charset="0"/>
-              </a:rPr>
-              <a:t>CAPTURA PENDIENTE</a:t>
-            </a:r>
-          </a:p>
-          <a:p>
-            <a:pPr algn="ctr"/>
-            <a:r>
-              <a:rPr lang="pt-BR" sz="900" i="1">
-                <a:solidFill>
-                  <a:srgbClr val="666666"/>
-                </a:solidFill>
-                <a:latin typeface="Arial" panose="020B0604020202020204" pitchFamily="34" charset="0"/>
-              </a:rPr>
-              <a:t>Código de controlador</a:t>
-            </a:r>
-            <a:endParaRPr lang="en-US" sz="900" i="1">
-              <a:solidFill>
-                <a:srgbClr val="666666"/>
-              </a:solidFill>
-              <a:latin typeface="Arial" panose="020B0604020202020204" pitchFamily="34" charset="0"/>
-            </a:endParaRPr>
-          </a:p>
-        </p:txBody>
-      </p:sp>
-      <p:sp>
-        <p:nvSpPr>
-          <p:cNvPr id="4" name="CAPTURA PENDIENTE - Código de modelo">
-            <a:extLst>
-              <a:ext uri="{FF2B5EF4-FFF2-40B4-BE49-F238E27FC236}">
-                <a16:creationId xmlns:a16="http://schemas.microsoft.com/office/drawing/2014/main" id="{D9BA546A-1E15-4A80-AA57-994B60F099F9}"/>
-              </a:ext>
-            </a:extLst>
-          </p:cNvPr>
-          <p:cNvSpPr/>
+      </p:pic>
+      <p:pic>
+        <p:nvPicPr>
+          <p:cNvPr id="305" name="image80.png"/>
+          <p:cNvPicPr/>
           <p:nvPr/>
-        </p:nvSpPr>
+        </p:nvPicPr>
+        <p:blipFill>
+          <a:blip r:embed="rId5"/>
+          <a:srcRect/>
+          <a:stretch>
+            <a:fillRect/>
+          </a:stretch>
+        </p:blipFill>
         <p:spPr>
           <a:xfrm>
             <a:off x="2611811" y="3836431"/>
@@ -22764,80 +22237,26 @@
           <a:prstGeom prst="rect">
             <a:avLst/>
           </a:prstGeom>
-          <a:solidFill>
-            <a:srgbClr val="FFFFFF"/>
-          </a:solidFill>
-          <a:ln w="15875">
+          <a:ln w="12700">
             <a:solidFill>
-              <a:srgbClr val="D9D9D9"/>
+              <a:srgbClr val="CCCCCC"/>
             </a:solidFill>
           </a:ln>
         </p:spPr>
-        <p:style>
-          <a:lnRef idx="2">
-            <a:schemeClr val="accent1">
-              <a:shade val="50000"/>
-            </a:schemeClr>
-          </a:lnRef>
-          <a:fillRef idx="1">
-            <a:schemeClr val="accent1"/>
-          </a:fillRef>
-          <a:effectRef idx="0">
-            <a:schemeClr val="accent1"/>
-          </a:effectRef>
-          <a:fontRef idx="minor">
-            <a:schemeClr val="lt1"/>
-          </a:fontRef>
-        </p:style>
-        <p:txBody>
-          <a:bodyPr wrap="square" lIns="76200" tIns="38100" rIns="76200" bIns="38100" rtlCol="0" anchor="ctr">
-            <a:noAutofit/>
-          </a:bodyPr>
-          <a:lstStyle/>
-          <a:p>
-            <a:pPr algn="ctr"/>
-            <a:r>
-              <a:rPr lang="pt-BR" sz="900" i="1">
-                <a:solidFill>
-                  <a:srgbClr val="666666"/>
-                </a:solidFill>
-                <a:latin typeface="Arial" panose="020B0604020202020204" pitchFamily="34" charset="0"/>
-              </a:rPr>
-              <a:t>CAPTURA PENDIENTE</a:t>
-            </a:r>
-          </a:p>
-          <a:p>
-            <a:pPr algn="ctr"/>
-            <a:r>
-              <a:rPr lang="pt-BR" sz="900" i="1">
-                <a:solidFill>
-                  <a:srgbClr val="666666"/>
-                </a:solidFill>
-                <a:latin typeface="Arial" panose="020B0604020202020204" pitchFamily="34" charset="0"/>
-              </a:rPr>
-              <a:t>Código de modelo</a:t>
-            </a:r>
-            <a:endParaRPr lang="en-US" sz="900" i="1">
-              <a:solidFill>
-                <a:srgbClr val="666666"/>
-              </a:solidFill>
-              <a:latin typeface="Arial" panose="020B0604020202020204" pitchFamily="34" charset="0"/>
-            </a:endParaRPr>
-          </a:p>
-        </p:txBody>
-      </p:sp>
-      <p:sp>
-        <p:nvSpPr>
-          <p:cNvPr id="5" name="CAPTURA PENDIENTE - Estructura de paquetes MVC">
-            <a:extLst>
-              <a:ext uri="{FF2B5EF4-FFF2-40B4-BE49-F238E27FC236}">
-                <a16:creationId xmlns:a16="http://schemas.microsoft.com/office/drawing/2014/main" id="{B197BBDF-1B0B-4C10-9B0A-1F8D65F9C273}"/>
-              </a:ext>
-            </a:extLst>
-          </p:cNvPr>
-          <p:cNvSpPr/>
+      </p:pic>
+      <p:pic>
+        <p:nvPicPr>
+          <p:cNvPr id="306" name="image81.png"/>
+          <p:cNvPicPr/>
           <p:nvPr/>
-        </p:nvSpPr>
+        </p:nvPicPr>
+        <p:blipFill>
+          <a:blip r:embed="rId6"/>
+          <a:srcRect/>
+          <a:stretch>
+            <a:fillRect/>
+          </a:stretch>
+        </p:blipFill>
         <p:spPr>
           <a:xfrm>
             <a:off x="5088311" y="2609850"/>
@@ -22846,62 +22265,13 @@
           <a:prstGeom prst="rect">
             <a:avLst/>
           </a:prstGeom>
-          <a:solidFill>
-            <a:srgbClr val="FFFFFF"/>
-          </a:solidFill>
-          <a:ln w="15875">
+          <a:ln w="12700">
             <a:solidFill>
-              <a:srgbClr val="D9D9D9"/>
+              <a:srgbClr val="CCCCCC"/>
             </a:solidFill>
           </a:ln>
         </p:spPr>
-        <p:style>
-          <a:lnRef idx="2">
-            <a:schemeClr val="accent1">
-              <a:shade val="50000"/>
-            </a:schemeClr>
-          </a:lnRef>
-          <a:fillRef idx="1">
-            <a:schemeClr val="accent1"/>
-          </a:fillRef>
-          <a:effectRef idx="0">
-            <a:schemeClr val="accent1"/>
-          </a:effectRef>
-          <a:fontRef idx="minor">
-            <a:schemeClr val="lt1"/>
-          </a:fontRef>
-        </p:style>
-        <p:txBody>
-          <a:bodyPr wrap="square" lIns="76200" tIns="38100" rIns="76200" bIns="38100" rtlCol="0" anchor="ctr">
-            <a:noAutofit/>
-          </a:bodyPr>
-          <a:lstStyle/>
-          <a:p>
-            <a:pPr algn="ctr"/>
-            <a:r>
-              <a:rPr lang="en-US" sz="900" i="1">
-                <a:solidFill>
-                  <a:srgbClr val="666666"/>
-                </a:solidFill>
-                <a:latin typeface="Arial" panose="020B0604020202020204" pitchFamily="34" charset="0"/>
-              </a:rPr>
-              <a:t>CAPTURA PENDIENTE</a:t>
-            </a:r>
-          </a:p>
-          <a:p>
-            <a:pPr algn="ctr"/>
-            <a:r>
-              <a:rPr lang="en-US" sz="900" i="1">
-                <a:solidFill>
-                  <a:srgbClr val="666666"/>
-                </a:solidFill>
-                <a:latin typeface="Arial" panose="020B0604020202020204" pitchFamily="34" charset="0"/>
-              </a:rPr>
-              <a:t>Estructura de paquetes MVC</a:t>
-            </a:r>
-          </a:p>
-        </p:txBody>
-      </p:sp>
+      </p:pic>
     </p:spTree>
   </p:cSld>
   <p:clrMapOvr>
@@ -23503,18 +22873,19 @@
           </a:p>
         </p:txBody>
       </p:sp>
-      <p:sp>
-        <p:nvSpPr>
-          <p:cNvPr id="2" name="CAPTURA PENDIENTE - Interfaz Swing de autenticación y conversión">
-            <a:extLst>
-              <a:ext uri="{FF2B5EF4-FFF2-40B4-BE49-F238E27FC236}">
-                <a16:creationId xmlns:a16="http://schemas.microsoft.com/office/drawing/2014/main" id="{72D8D44A-0A8E-4206-9ECA-659FC89E010E}"/>
-              </a:ext>
-            </a:extLst>
-          </p:cNvPr>
-          <p:cNvSpPr/>
+      <p:pic>
+        <p:nvPicPr>
+          <p:cNvPr id="311" name="image87.png"/>
+          <p:cNvPicPr/>
           <p:nvPr/>
-        </p:nvSpPr>
+        </p:nvPicPr>
+        <p:blipFill>
+          <a:blip r:embed="rId3"/>
+          <a:srcRect/>
+          <a:stretch>
+            <a:fillRect/>
+          </a:stretch>
+        </p:blipFill>
         <p:spPr>
           <a:xfrm>
             <a:off x="699248" y="2831802"/>
@@ -23523,68 +22894,13 @@
           <a:prstGeom prst="rect">
             <a:avLst/>
           </a:prstGeom>
-          <a:solidFill>
-            <a:srgbClr val="FFFFFF"/>
-          </a:solidFill>
-          <a:ln w="15875">
+          <a:ln w="12700">
             <a:solidFill>
-              <a:srgbClr val="D9D9D9"/>
+              <a:srgbClr val="CCCCCC"/>
             </a:solidFill>
           </a:ln>
         </p:spPr>
-        <p:style>
-          <a:lnRef idx="2">
-            <a:schemeClr val="accent1">
-              <a:shade val="50000"/>
-            </a:schemeClr>
-          </a:lnRef>
-          <a:fillRef idx="1">
-            <a:schemeClr val="accent1"/>
-          </a:fillRef>
-          <a:effectRef idx="0">
-            <a:schemeClr val="accent1"/>
-          </a:effectRef>
-          <a:fontRef idx="minor">
-            <a:schemeClr val="lt1"/>
-          </a:fontRef>
-        </p:style>
-        <p:txBody>
-          <a:bodyPr wrap="square" lIns="76200" tIns="38100" rIns="76200" bIns="38100" rtlCol="0" anchor="ctr">
-            <a:noAutofit/>
-          </a:bodyPr>
-          <a:lstStyle/>
-          <a:p>
-            <a:pPr algn="ctr"/>
-            <a:r>
-              <a:rPr lang="es-ES" sz="900" i="1">
-                <a:solidFill>
-                  <a:srgbClr val="666666"/>
-                </a:solidFill>
-                <a:latin typeface="Arial" panose="020B0604020202020204" pitchFamily="34" charset="0"/>
-              </a:rPr>
-              <a:t>CAPTURA PENDIENTE</a:t>
-            </a:r>
-          </a:p>
-          <a:p>
-            <a:pPr algn="ctr"/>
-            <a:r>
-              <a:rPr lang="es-ES" sz="900" i="1">
-                <a:solidFill>
-                  <a:srgbClr val="666666"/>
-                </a:solidFill>
-                <a:latin typeface="Arial" panose="020B0604020202020204" pitchFamily="34" charset="0"/>
-              </a:rPr>
-              <a:t>Interfaz Swing de autenticación y conversión</a:t>
-            </a:r>
-            <a:endParaRPr lang="en-US" sz="900" i="1">
-              <a:solidFill>
-                <a:srgbClr val="666666"/>
-              </a:solidFill>
-              <a:latin typeface="Arial" panose="020B0604020202020204" pitchFamily="34" charset="0"/>
-            </a:endParaRPr>
-          </a:p>
-        </p:txBody>
-      </p:sp>
+      </p:pic>
     </p:spTree>
   </p:cSld>
   <p:clrMapOvr>
@@ -24186,18 +23502,19 @@
           </a:p>
         </p:txBody>
       </p:sp>
-      <p:sp>
-        <p:nvSpPr>
-          <p:cNvPr id="2" name="CAPTURA PENDIENTE - Pantalla de inicio de sesión del escritorio">
-            <a:extLst>
-              <a:ext uri="{FF2B5EF4-FFF2-40B4-BE49-F238E27FC236}">
-                <a16:creationId xmlns:a16="http://schemas.microsoft.com/office/drawing/2014/main" id="{DDBE8347-1A58-405A-86AC-1D65FA07AFBF}"/>
-              </a:ext>
-            </a:extLst>
-          </p:cNvPr>
-          <p:cNvSpPr/>
+      <p:pic>
+        <p:nvPicPr>
+          <p:cNvPr id="319" name="image121.png"/>
+          <p:cNvPicPr/>
           <p:nvPr/>
-        </p:nvSpPr>
+        </p:nvPicPr>
+        <p:blipFill>
+          <a:blip r:embed="rId3"/>
+          <a:srcRect/>
+          <a:stretch>
+            <a:fillRect/>
+          </a:stretch>
+        </p:blipFill>
         <p:spPr>
           <a:xfrm>
             <a:off x="581192" y="2329030"/>
@@ -24206,68 +23523,13 @@
           <a:prstGeom prst="rect">
             <a:avLst/>
           </a:prstGeom>
-          <a:solidFill>
-            <a:srgbClr val="FFFFFF"/>
-          </a:solidFill>
-          <a:ln w="15875">
+          <a:ln w="12700">
             <a:solidFill>
-              <a:srgbClr val="D9D9D9"/>
+              <a:srgbClr val="CCCCCC"/>
             </a:solidFill>
           </a:ln>
         </p:spPr>
-        <p:style>
-          <a:lnRef idx="2">
-            <a:schemeClr val="accent1">
-              <a:shade val="50000"/>
-            </a:schemeClr>
-          </a:lnRef>
-          <a:fillRef idx="1">
-            <a:schemeClr val="accent1"/>
-          </a:fillRef>
-          <a:effectRef idx="0">
-            <a:schemeClr val="accent1"/>
-          </a:effectRef>
-          <a:fontRef idx="minor">
-            <a:schemeClr val="lt1"/>
-          </a:fontRef>
-        </p:style>
-        <p:txBody>
-          <a:bodyPr wrap="square" lIns="76200" tIns="38100" rIns="76200" bIns="38100" rtlCol="0" anchor="ctr">
-            <a:noAutofit/>
-          </a:bodyPr>
-          <a:lstStyle/>
-          <a:p>
-            <a:pPr algn="ctr"/>
-            <a:r>
-              <a:rPr lang="es-ES" sz="900" i="1">
-                <a:solidFill>
-                  <a:srgbClr val="666666"/>
-                </a:solidFill>
-                <a:latin typeface="Arial" panose="020B0604020202020204" pitchFamily="34" charset="0"/>
-              </a:rPr>
-              <a:t>CAPTURA PENDIENTE</a:t>
-            </a:r>
-          </a:p>
-          <a:p>
-            <a:pPr algn="ctr"/>
-            <a:r>
-              <a:rPr lang="es-ES" sz="900" i="1">
-                <a:solidFill>
-                  <a:srgbClr val="666666"/>
-                </a:solidFill>
-                <a:latin typeface="Arial" panose="020B0604020202020204" pitchFamily="34" charset="0"/>
-              </a:rPr>
-              <a:t>Pantalla de inicio de sesión del escritorio</a:t>
-            </a:r>
-            <a:endParaRPr lang="en-US" sz="900" i="1">
-              <a:solidFill>
-                <a:srgbClr val="666666"/>
-              </a:solidFill>
-              <a:latin typeface="Arial" panose="020B0604020202020204" pitchFamily="34" charset="0"/>
-            </a:endParaRPr>
-          </a:p>
-        </p:txBody>
-      </p:sp>
+      </p:pic>
     </p:spTree>
   </p:cSld>
   <p:clrMapOvr>
@@ -24869,18 +24131,19 @@
           </a:p>
         </p:txBody>
       </p:sp>
-      <p:sp>
-        <p:nvSpPr>
-          <p:cNvPr id="2" name="CAPTURA PENDIENTE - Formulario de conversión del escritorio">
-            <a:extLst>
-              <a:ext uri="{FF2B5EF4-FFF2-40B4-BE49-F238E27FC236}">
-                <a16:creationId xmlns:a16="http://schemas.microsoft.com/office/drawing/2014/main" id="{E5A38DE0-325D-4447-9F55-51FC2D2555CE}"/>
-              </a:ext>
-            </a:extLst>
-          </p:cNvPr>
-          <p:cNvSpPr/>
+      <p:pic>
+        <p:nvPicPr>
+          <p:cNvPr id="337" name="image122.png"/>
+          <p:cNvPicPr/>
           <p:nvPr/>
-        </p:nvSpPr>
+        </p:nvPicPr>
+        <p:blipFill>
+          <a:blip r:embed="rId3"/>
+          <a:srcRect/>
+          <a:stretch>
+            <a:fillRect/>
+          </a:stretch>
+        </p:blipFill>
         <p:spPr>
           <a:xfrm>
             <a:off x="1131103" y="2513572"/>
@@ -24889,68 +24152,13 @@
           <a:prstGeom prst="rect">
             <a:avLst/>
           </a:prstGeom>
-          <a:solidFill>
-            <a:srgbClr val="FFFFFF"/>
-          </a:solidFill>
-          <a:ln w="15875">
+          <a:ln w="12700">
             <a:solidFill>
-              <a:srgbClr val="D9D9D9"/>
+              <a:srgbClr val="CCCCCC"/>
             </a:solidFill>
           </a:ln>
         </p:spPr>
-        <p:style>
-          <a:lnRef idx="2">
-            <a:schemeClr val="accent1">
-              <a:shade val="50000"/>
-            </a:schemeClr>
-          </a:lnRef>
-          <a:fillRef idx="1">
-            <a:schemeClr val="accent1"/>
-          </a:fillRef>
-          <a:effectRef idx="0">
-            <a:schemeClr val="accent1"/>
-          </a:effectRef>
-          <a:fontRef idx="minor">
-            <a:schemeClr val="lt1"/>
-          </a:fontRef>
-        </p:style>
-        <p:txBody>
-          <a:bodyPr wrap="square" lIns="76200" tIns="38100" rIns="76200" bIns="38100" rtlCol="0" anchor="ctr">
-            <a:noAutofit/>
-          </a:bodyPr>
-          <a:lstStyle/>
-          <a:p>
-            <a:pPr algn="ctr"/>
-            <a:r>
-              <a:rPr lang="es-ES" sz="900" i="1">
-                <a:solidFill>
-                  <a:srgbClr val="666666"/>
-                </a:solidFill>
-                <a:latin typeface="Arial" panose="020B0604020202020204" pitchFamily="34" charset="0"/>
-              </a:rPr>
-              <a:t>CAPTURA PENDIENTE</a:t>
-            </a:r>
-          </a:p>
-          <a:p>
-            <a:pPr algn="ctr"/>
-            <a:r>
-              <a:rPr lang="es-ES" sz="900" i="1">
-                <a:solidFill>
-                  <a:srgbClr val="666666"/>
-                </a:solidFill>
-                <a:latin typeface="Arial" panose="020B0604020202020204" pitchFamily="34" charset="0"/>
-              </a:rPr>
-              <a:t>Formulario de conversión del escritorio</a:t>
-            </a:r>
-            <a:endParaRPr lang="en-US" sz="900" i="1">
-              <a:solidFill>
-                <a:srgbClr val="666666"/>
-              </a:solidFill>
-              <a:latin typeface="Arial" panose="020B0604020202020204" pitchFamily="34" charset="0"/>
-            </a:endParaRPr>
-          </a:p>
-        </p:txBody>
-      </p:sp>
+      </p:pic>
     </p:spTree>
   </p:cSld>
   <p:clrMapOvr>
@@ -25617,18 +24825,19 @@
           </a:p>
         </p:txBody>
       </p:sp>
-      <p:sp>
-        <p:nvSpPr>
-          <p:cNvPr id="2" name="CAPTURA PENDIENTE - Configuración de Jetty y Servlets">
-            <a:extLst>
-              <a:ext uri="{FF2B5EF4-FFF2-40B4-BE49-F238E27FC236}">
-                <a16:creationId xmlns:a16="http://schemas.microsoft.com/office/drawing/2014/main" id="{16593287-0CEF-49B8-974F-2F1AE8A0C15E}"/>
-              </a:ext>
-            </a:extLst>
-          </p:cNvPr>
-          <p:cNvSpPr/>
+      <p:pic>
+        <p:nvPicPr>
+          <p:cNvPr id="345" name="image100.png"/>
+          <p:cNvPicPr/>
           <p:nvPr/>
-        </p:nvSpPr>
+        </p:nvPicPr>
+        <p:blipFill>
+          <a:blip r:embed="rId3"/>
+          <a:srcRect/>
+          <a:stretch>
+            <a:fillRect/>
+          </a:stretch>
+        </p:blipFill>
         <p:spPr>
           <a:xfrm>
             <a:off x="3863999" y="3524211"/>
@@ -25637,80 +24846,26 @@
           <a:prstGeom prst="rect">
             <a:avLst/>
           </a:prstGeom>
-          <a:solidFill>
-            <a:srgbClr val="FFFFFF"/>
-          </a:solidFill>
-          <a:ln w="15875">
+          <a:ln w="12700">
             <a:solidFill>
-              <a:srgbClr val="D9D9D9"/>
+              <a:srgbClr val="CCCCCC"/>
             </a:solidFill>
           </a:ln>
         </p:spPr>
-        <p:style>
-          <a:lnRef idx="2">
-            <a:schemeClr val="accent1">
-              <a:shade val="50000"/>
-            </a:schemeClr>
-          </a:lnRef>
-          <a:fillRef idx="1">
-            <a:schemeClr val="accent1"/>
-          </a:fillRef>
-          <a:effectRef idx="0">
-            <a:schemeClr val="accent1"/>
-          </a:effectRef>
-          <a:fontRef idx="minor">
-            <a:schemeClr val="lt1"/>
-          </a:fontRef>
-        </p:style>
-        <p:txBody>
-          <a:bodyPr wrap="square" lIns="76200" tIns="38100" rIns="76200" bIns="38100" rtlCol="0" anchor="ctr">
-            <a:noAutofit/>
-          </a:bodyPr>
-          <a:lstStyle/>
-          <a:p>
-            <a:pPr algn="ctr"/>
-            <a:r>
-              <a:rPr lang="es-ES" sz="900" i="1">
-                <a:solidFill>
-                  <a:srgbClr val="666666"/>
-                </a:solidFill>
-                <a:latin typeface="Arial" panose="020B0604020202020204" pitchFamily="34" charset="0"/>
-              </a:rPr>
-              <a:t>CAPTURA PENDIENTE</a:t>
-            </a:r>
-          </a:p>
-          <a:p>
-            <a:pPr algn="ctr"/>
-            <a:r>
-              <a:rPr lang="es-ES" sz="900" i="1">
-                <a:solidFill>
-                  <a:srgbClr val="666666"/>
-                </a:solidFill>
-                <a:latin typeface="Arial" panose="020B0604020202020204" pitchFamily="34" charset="0"/>
-              </a:rPr>
-              <a:t>Configuración de Jetty y Servlets</a:t>
-            </a:r>
-            <a:endParaRPr lang="en-US" sz="900" i="1">
-              <a:solidFill>
-                <a:srgbClr val="666666"/>
-              </a:solidFill>
-              <a:latin typeface="Arial" panose="020B0604020202020204" pitchFamily="34" charset="0"/>
-            </a:endParaRPr>
-          </a:p>
-        </p:txBody>
-      </p:sp>
-      <p:sp>
-        <p:nvSpPr>
-          <p:cNvPr id="3" name="CAPTURA PENDIENTE - Estructura del cliente web">
-            <a:extLst>
-              <a:ext uri="{FF2B5EF4-FFF2-40B4-BE49-F238E27FC236}">
-                <a16:creationId xmlns:a16="http://schemas.microsoft.com/office/drawing/2014/main" id="{9547CBA9-C1D8-4B24-853B-4A2AF89BF58F}"/>
-              </a:ext>
-            </a:extLst>
-          </p:cNvPr>
-          <p:cNvSpPr/>
+      </p:pic>
+      <p:pic>
+        <p:nvPicPr>
+          <p:cNvPr id="346" name="image101.png"/>
+          <p:cNvPicPr/>
           <p:nvPr/>
-        </p:nvSpPr>
+        </p:nvPicPr>
+        <p:blipFill>
+          <a:blip r:embed="rId4"/>
+          <a:srcRect/>
+          <a:stretch>
+            <a:fillRect/>
+          </a:stretch>
+        </p:blipFill>
         <p:spPr>
           <a:xfrm>
             <a:off x="1211356" y="3839056"/>
@@ -25719,68 +24874,13 @@
           <a:prstGeom prst="rect">
             <a:avLst/>
           </a:prstGeom>
-          <a:solidFill>
-            <a:srgbClr val="FFFFFF"/>
-          </a:solidFill>
-          <a:ln w="15875">
+          <a:ln w="12700">
             <a:solidFill>
-              <a:srgbClr val="D9D9D9"/>
+              <a:srgbClr val="CCCCCC"/>
             </a:solidFill>
           </a:ln>
         </p:spPr>
-        <p:style>
-          <a:lnRef idx="2">
-            <a:schemeClr val="accent1">
-              <a:shade val="50000"/>
-            </a:schemeClr>
-          </a:lnRef>
-          <a:fillRef idx="1">
-            <a:schemeClr val="accent1"/>
-          </a:fillRef>
-          <a:effectRef idx="0">
-            <a:schemeClr val="accent1"/>
-          </a:effectRef>
-          <a:fontRef idx="minor">
-            <a:schemeClr val="lt1"/>
-          </a:fontRef>
-        </p:style>
-        <p:txBody>
-          <a:bodyPr wrap="square" lIns="76200" tIns="38100" rIns="76200" bIns="38100" rtlCol="0" anchor="ctr">
-            <a:noAutofit/>
-          </a:bodyPr>
-          <a:lstStyle/>
-          <a:p>
-            <a:pPr algn="ctr"/>
-            <a:r>
-              <a:rPr lang="es-ES" sz="900" i="1">
-                <a:solidFill>
-                  <a:srgbClr val="666666"/>
-                </a:solidFill>
-                <a:latin typeface="Arial" panose="020B0604020202020204" pitchFamily="34" charset="0"/>
-              </a:rPr>
-              <a:t>CAPTURA PENDIENTE</a:t>
-            </a:r>
-          </a:p>
-          <a:p>
-            <a:pPr algn="ctr"/>
-            <a:r>
-              <a:rPr lang="es-ES" sz="900" i="1">
-                <a:solidFill>
-                  <a:srgbClr val="666666"/>
-                </a:solidFill>
-                <a:latin typeface="Arial" panose="020B0604020202020204" pitchFamily="34" charset="0"/>
-              </a:rPr>
-              <a:t>Estructura del cliente web</a:t>
-            </a:r>
-            <a:endParaRPr lang="en-US" sz="900" i="1">
-              <a:solidFill>
-                <a:srgbClr val="666666"/>
-              </a:solidFill>
-              <a:latin typeface="Arial" panose="020B0604020202020204" pitchFamily="34" charset="0"/>
-            </a:endParaRPr>
-          </a:p>
-        </p:txBody>
-      </p:sp>
+      </p:pic>
     </p:spTree>
   </p:cSld>
   <p:clrMapOvr>
@@ -26430,18 +25530,19 @@
           </a:p>
         </p:txBody>
       </p:sp>
-      <p:sp>
-        <p:nvSpPr>
-          <p:cNvPr id="2" name="CAPTURA PENDIENTE - Formulario y respuesta del cliente web">
-            <a:extLst>
-              <a:ext uri="{FF2B5EF4-FFF2-40B4-BE49-F238E27FC236}">
-                <a16:creationId xmlns:a16="http://schemas.microsoft.com/office/drawing/2014/main" id="{406C6AF6-33CF-47B3-8FB5-DCC2D1E16140}"/>
-              </a:ext>
-            </a:extLst>
-          </p:cNvPr>
-          <p:cNvSpPr/>
+      <p:pic>
+        <p:nvPicPr>
+          <p:cNvPr id="379" name="image102.png"/>
+          <p:cNvPicPr/>
           <p:nvPr/>
-        </p:nvSpPr>
+        </p:nvPicPr>
+        <p:blipFill>
+          <a:blip r:embed="rId3"/>
+          <a:srcRect/>
+          <a:stretch>
+            <a:fillRect/>
+          </a:stretch>
+        </p:blipFill>
         <p:spPr>
           <a:xfrm>
             <a:off x="3679277" y="3132944"/>
@@ -26450,80 +25551,26 @@
           <a:prstGeom prst="rect">
             <a:avLst/>
           </a:prstGeom>
-          <a:solidFill>
-            <a:srgbClr val="FFFFFF"/>
-          </a:solidFill>
-          <a:ln w="15875">
+          <a:ln w="12700">
             <a:solidFill>
-              <a:srgbClr val="D9D9D9"/>
+              <a:srgbClr val="CCCCCC"/>
             </a:solidFill>
           </a:ln>
         </p:spPr>
-        <p:style>
-          <a:lnRef idx="2">
-            <a:schemeClr val="accent1">
-              <a:shade val="50000"/>
-            </a:schemeClr>
-          </a:lnRef>
-          <a:fillRef idx="1">
-            <a:schemeClr val="accent1"/>
-          </a:fillRef>
-          <a:effectRef idx="0">
-            <a:schemeClr val="accent1"/>
-          </a:effectRef>
-          <a:fontRef idx="minor">
-            <a:schemeClr val="lt1"/>
-          </a:fontRef>
-        </p:style>
-        <p:txBody>
-          <a:bodyPr wrap="square" lIns="76200" tIns="38100" rIns="76200" bIns="38100" rtlCol="0" anchor="ctr">
-            <a:noAutofit/>
-          </a:bodyPr>
-          <a:lstStyle/>
-          <a:p>
-            <a:pPr algn="ctr"/>
-            <a:r>
-              <a:rPr lang="es-ES" sz="900" i="1">
-                <a:solidFill>
-                  <a:srgbClr val="666666"/>
-                </a:solidFill>
-                <a:latin typeface="Arial" panose="020B0604020202020204" pitchFamily="34" charset="0"/>
-              </a:rPr>
-              <a:t>CAPTURA PENDIENTE</a:t>
-            </a:r>
-          </a:p>
-          <a:p>
-            <a:pPr algn="ctr"/>
-            <a:r>
-              <a:rPr lang="es-ES" sz="900" i="1">
-                <a:solidFill>
-                  <a:srgbClr val="666666"/>
-                </a:solidFill>
-                <a:latin typeface="Arial" panose="020B0604020202020204" pitchFamily="34" charset="0"/>
-              </a:rPr>
-              <a:t>Formulario y respuesta del cliente web</a:t>
-            </a:r>
-            <a:endParaRPr lang="en-US" sz="900" i="1">
-              <a:solidFill>
-                <a:srgbClr val="666666"/>
-              </a:solidFill>
-              <a:latin typeface="Arial" panose="020B0604020202020204" pitchFamily="34" charset="0"/>
-            </a:endParaRPr>
-          </a:p>
-        </p:txBody>
-      </p:sp>
-      <p:sp>
-        <p:nvSpPr>
-          <p:cNvPr id="4" name="CAPTURA PENDIENTE - Pantalla web de conversión">
-            <a:extLst>
-              <a:ext uri="{FF2B5EF4-FFF2-40B4-BE49-F238E27FC236}">
-                <a16:creationId xmlns:a16="http://schemas.microsoft.com/office/drawing/2014/main" id="{5F4C8FCF-4366-4C4F-9FAD-C323C0C23A42}"/>
-              </a:ext>
-            </a:extLst>
-          </p:cNvPr>
-          <p:cNvSpPr/>
+      </p:pic>
+      <p:pic>
+        <p:nvPicPr>
+          <p:cNvPr id="380" name="image103.png"/>
+          <p:cNvPicPr/>
           <p:nvPr/>
-        </p:nvSpPr>
+        </p:nvPicPr>
+        <p:blipFill>
+          <a:blip r:embed="rId4"/>
+          <a:srcRect/>
+          <a:stretch>
+            <a:fillRect/>
+          </a:stretch>
+        </p:blipFill>
         <p:spPr>
           <a:xfrm>
             <a:off x="841168" y="3132944"/>
@@ -26532,68 +25579,13 @@
           <a:prstGeom prst="rect">
             <a:avLst/>
           </a:prstGeom>
-          <a:solidFill>
-            <a:srgbClr val="FFFFFF"/>
-          </a:solidFill>
-          <a:ln w="15875">
+          <a:ln w="12700">
             <a:solidFill>
-              <a:srgbClr val="D9D9D9"/>
+              <a:srgbClr val="CCCCCC"/>
             </a:solidFill>
           </a:ln>
         </p:spPr>
-        <p:style>
-          <a:lnRef idx="2">
-            <a:schemeClr val="accent1">
-              <a:shade val="50000"/>
-            </a:schemeClr>
-          </a:lnRef>
-          <a:fillRef idx="1">
-            <a:schemeClr val="accent1"/>
-          </a:fillRef>
-          <a:effectRef idx="0">
-            <a:schemeClr val="accent1"/>
-          </a:effectRef>
-          <a:fontRef idx="minor">
-            <a:schemeClr val="lt1"/>
-          </a:fontRef>
-        </p:style>
-        <p:txBody>
-          <a:bodyPr wrap="square" lIns="76200" tIns="38100" rIns="76200" bIns="38100" rtlCol="0" anchor="ctr">
-            <a:noAutofit/>
-          </a:bodyPr>
-          <a:lstStyle/>
-          <a:p>
-            <a:pPr algn="ctr"/>
-            <a:r>
-              <a:rPr lang="es-ES" sz="900" i="1">
-                <a:solidFill>
-                  <a:srgbClr val="666666"/>
-                </a:solidFill>
-                <a:latin typeface="Arial" panose="020B0604020202020204" pitchFamily="34" charset="0"/>
-              </a:rPr>
-              <a:t>CAPTURA PENDIENTE</a:t>
-            </a:r>
-          </a:p>
-          <a:p>
-            <a:pPr algn="ctr"/>
-            <a:r>
-              <a:rPr lang="es-ES" sz="900" i="1">
-                <a:solidFill>
-                  <a:srgbClr val="666666"/>
-                </a:solidFill>
-                <a:latin typeface="Arial" panose="020B0604020202020204" pitchFamily="34" charset="0"/>
-              </a:rPr>
-              <a:t>Pantalla web de conversión</a:t>
-            </a:r>
-            <a:endParaRPr lang="en-US" sz="900" i="1">
-              <a:solidFill>
-                <a:srgbClr val="666666"/>
-              </a:solidFill>
-              <a:latin typeface="Arial" panose="020B0604020202020204" pitchFamily="34" charset="0"/>
-            </a:endParaRPr>
-          </a:p>
-        </p:txBody>
-      </p:sp>
+      </p:pic>
     </p:spTree>
   </p:cSld>
   <p:clrMapOvr>
@@ -27672,18 +26664,19 @@
           </a:p>
         </p:txBody>
       </p:sp>
-      <p:sp>
-        <p:nvSpPr>
-          <p:cNvPr id="2" name="CAPTURA PENDIENTE - Pantalla web de inicio de sesión">
-            <a:extLst>
-              <a:ext uri="{FF2B5EF4-FFF2-40B4-BE49-F238E27FC236}">
-                <a16:creationId xmlns:a16="http://schemas.microsoft.com/office/drawing/2014/main" id="{D3F36737-3CBD-4B2C-B211-D67B93A6A9C6}"/>
-              </a:ext>
-            </a:extLst>
-          </p:cNvPr>
-          <p:cNvSpPr/>
+      <p:pic>
+        <p:nvPicPr>
+          <p:cNvPr id="387" name="image109.png"/>
+          <p:cNvPicPr/>
           <p:nvPr/>
-        </p:nvSpPr>
+        </p:nvPicPr>
+        <p:blipFill>
+          <a:blip r:embed="rId3"/>
+          <a:srcRect/>
+          <a:stretch>
+            <a:fillRect/>
+          </a:stretch>
+        </p:blipFill>
         <p:spPr>
           <a:xfrm>
             <a:off x="2804070" y="2850777"/>
@@ -27692,68 +26685,13 @@
           <a:prstGeom prst="rect">
             <a:avLst/>
           </a:prstGeom>
-          <a:solidFill>
-            <a:srgbClr val="FFFFFF"/>
-          </a:solidFill>
-          <a:ln w="15875">
+          <a:ln w="12700">
             <a:solidFill>
-              <a:srgbClr val="D9D9D9"/>
+              <a:srgbClr val="CCCCCC"/>
             </a:solidFill>
           </a:ln>
         </p:spPr>
-        <p:style>
-          <a:lnRef idx="2">
-            <a:schemeClr val="accent1">
-              <a:shade val="50000"/>
-            </a:schemeClr>
-          </a:lnRef>
-          <a:fillRef idx="1">
-            <a:schemeClr val="accent1"/>
-          </a:fillRef>
-          <a:effectRef idx="0">
-            <a:schemeClr val="accent1"/>
-          </a:effectRef>
-          <a:fontRef idx="minor">
-            <a:schemeClr val="lt1"/>
-          </a:fontRef>
-        </p:style>
-        <p:txBody>
-          <a:bodyPr wrap="square" lIns="76200" tIns="38100" rIns="76200" bIns="38100" rtlCol="0" anchor="ctr">
-            <a:noAutofit/>
-          </a:bodyPr>
-          <a:lstStyle/>
-          <a:p>
-            <a:pPr algn="ctr"/>
-            <a:r>
-              <a:rPr lang="es-ES" sz="900" i="1">
-                <a:solidFill>
-                  <a:srgbClr val="666666"/>
-                </a:solidFill>
-                <a:latin typeface="Arial" panose="020B0604020202020204" pitchFamily="34" charset="0"/>
-              </a:rPr>
-              <a:t>CAPTURA PENDIENTE</a:t>
-            </a:r>
-          </a:p>
-          <a:p>
-            <a:pPr algn="ctr"/>
-            <a:r>
-              <a:rPr lang="es-ES" sz="900" i="1">
-                <a:solidFill>
-                  <a:srgbClr val="666666"/>
-                </a:solidFill>
-                <a:latin typeface="Arial" panose="020B0604020202020204" pitchFamily="34" charset="0"/>
-              </a:rPr>
-              <a:t>Pantalla web de inicio de sesión</a:t>
-            </a:r>
-            <a:endParaRPr lang="en-US" sz="900" i="1">
-              <a:solidFill>
-                <a:srgbClr val="666666"/>
-              </a:solidFill>
-              <a:latin typeface="Arial" panose="020B0604020202020204" pitchFamily="34" charset="0"/>
-            </a:endParaRPr>
-          </a:p>
-        </p:txBody>
-      </p:sp>
+      </p:pic>
     </p:spTree>
   </p:cSld>
   <p:clrMapOvr>
@@ -28356,18 +27294,19 @@
           </a:p>
         </p:txBody>
       </p:sp>
-      <p:sp>
-        <p:nvSpPr>
-          <p:cNvPr id="2" name="CAPTURA PENDIENTE - Cliente web ejecutándose en el navegador">
-            <a:extLst>
-              <a:ext uri="{FF2B5EF4-FFF2-40B4-BE49-F238E27FC236}">
-                <a16:creationId xmlns:a16="http://schemas.microsoft.com/office/drawing/2014/main" id="{20B3726C-F6B4-45C9-AC26-56D387AC5E00}"/>
-              </a:ext>
-            </a:extLst>
-          </p:cNvPr>
-          <p:cNvSpPr/>
+      <p:pic>
+        <p:nvPicPr>
+          <p:cNvPr id="403" name="image125.png"/>
+          <p:cNvPicPr/>
           <p:nvPr/>
-        </p:nvSpPr>
+        </p:nvPicPr>
+        <p:blipFill>
+          <a:blip r:embed="rId3"/>
+          <a:srcRect/>
+          <a:stretch>
+            <a:fillRect/>
+          </a:stretch>
+        </p:blipFill>
         <p:spPr>
           <a:xfrm>
             <a:off x="3135268" y="3257334"/>
@@ -28376,68 +27315,13 @@
           <a:prstGeom prst="rect">
             <a:avLst/>
           </a:prstGeom>
-          <a:solidFill>
-            <a:srgbClr val="FFFFFF"/>
-          </a:solidFill>
-          <a:ln w="15875">
+          <a:ln w="12700">
             <a:solidFill>
-              <a:srgbClr val="D9D9D9"/>
+              <a:srgbClr val="CCCCCC"/>
             </a:solidFill>
           </a:ln>
         </p:spPr>
-        <p:style>
-          <a:lnRef idx="2">
-            <a:schemeClr val="accent1">
-              <a:shade val="50000"/>
-            </a:schemeClr>
-          </a:lnRef>
-          <a:fillRef idx="1">
-            <a:schemeClr val="accent1"/>
-          </a:fillRef>
-          <a:effectRef idx="0">
-            <a:schemeClr val="accent1"/>
-          </a:effectRef>
-          <a:fontRef idx="minor">
-            <a:schemeClr val="lt1"/>
-          </a:fontRef>
-        </p:style>
-        <p:txBody>
-          <a:bodyPr wrap="square" lIns="76200" tIns="38100" rIns="76200" bIns="38100" rtlCol="0" anchor="ctr">
-            <a:noAutofit/>
-          </a:bodyPr>
-          <a:lstStyle/>
-          <a:p>
-            <a:pPr algn="ctr"/>
-            <a:r>
-              <a:rPr lang="es-ES" sz="900" i="1">
-                <a:solidFill>
-                  <a:srgbClr val="666666"/>
-                </a:solidFill>
-                <a:latin typeface="Arial" panose="020B0604020202020204" pitchFamily="34" charset="0"/>
-              </a:rPr>
-              <a:t>CAPTURA PENDIENTE</a:t>
-            </a:r>
-          </a:p>
-          <a:p>
-            <a:pPr algn="ctr"/>
-            <a:r>
-              <a:rPr lang="es-ES" sz="900" i="1">
-                <a:solidFill>
-                  <a:srgbClr val="666666"/>
-                </a:solidFill>
-                <a:latin typeface="Arial" panose="020B0604020202020204" pitchFamily="34" charset="0"/>
-              </a:rPr>
-              <a:t>Cliente web ejecutándose en el navegador</a:t>
-            </a:r>
-            <a:endParaRPr lang="en-US" sz="900" i="1">
-              <a:solidFill>
-                <a:srgbClr val="666666"/>
-              </a:solidFill>
-              <a:latin typeface="Arial" panose="020B0604020202020204" pitchFamily="34" charset="0"/>
-            </a:endParaRPr>
-          </a:p>
-        </p:txBody>
-      </p:sp>
+      </p:pic>
     </p:spTree>
   </p:cSld>
   <p:clrMapOvr>
@@ -29040,18 +27924,19 @@
           </a:p>
         </p:txBody>
       </p:sp>
-      <p:sp>
-        <p:nvSpPr>
-          <p:cNvPr id="2" name="CAPTURA PENDIENTE - Autenticación en el cliente web">
-            <a:extLst>
-              <a:ext uri="{FF2B5EF4-FFF2-40B4-BE49-F238E27FC236}">
-                <a16:creationId xmlns:a16="http://schemas.microsoft.com/office/drawing/2014/main" id="{EF175D66-5604-41C8-8DB4-58DDF5F7B0ED}"/>
-              </a:ext>
-            </a:extLst>
-          </p:cNvPr>
-          <p:cNvSpPr/>
+      <p:pic>
+        <p:nvPicPr>
+          <p:cNvPr id="413" name="image126.png"/>
+          <p:cNvPicPr/>
           <p:nvPr/>
-        </p:nvSpPr>
+        </p:nvPicPr>
+        <p:blipFill>
+          <a:blip r:embed="rId3"/>
+          <a:srcRect/>
+          <a:stretch>
+            <a:fillRect/>
+          </a:stretch>
+        </p:blipFill>
         <p:spPr>
           <a:xfrm>
             <a:off x="803359" y="2804085"/>
@@ -29060,68 +27945,13 @@
           <a:prstGeom prst="rect">
             <a:avLst/>
           </a:prstGeom>
-          <a:solidFill>
-            <a:srgbClr val="FFFFFF"/>
-          </a:solidFill>
-          <a:ln w="15875">
+          <a:ln w="12700">
             <a:solidFill>
-              <a:srgbClr val="D9D9D9"/>
+              <a:srgbClr val="CCCCCC"/>
             </a:solidFill>
           </a:ln>
         </p:spPr>
-        <p:style>
-          <a:lnRef idx="2">
-            <a:schemeClr val="accent1">
-              <a:shade val="50000"/>
-            </a:schemeClr>
-          </a:lnRef>
-          <a:fillRef idx="1">
-            <a:schemeClr val="accent1"/>
-          </a:fillRef>
-          <a:effectRef idx="0">
-            <a:schemeClr val="accent1"/>
-          </a:effectRef>
-          <a:fontRef idx="minor">
-            <a:schemeClr val="lt1"/>
-          </a:fontRef>
-        </p:style>
-        <p:txBody>
-          <a:bodyPr wrap="square" lIns="76200" tIns="38100" rIns="76200" bIns="38100" rtlCol="0" anchor="ctr">
-            <a:noAutofit/>
-          </a:bodyPr>
-          <a:lstStyle/>
-          <a:p>
-            <a:pPr algn="ctr"/>
-            <a:r>
-              <a:rPr lang="es-ES" sz="900" i="1">
-                <a:solidFill>
-                  <a:srgbClr val="666666"/>
-                </a:solidFill>
-                <a:latin typeface="Arial" panose="020B0604020202020204" pitchFamily="34" charset="0"/>
-              </a:rPr>
-              <a:t>CAPTURA PENDIENTE</a:t>
-            </a:r>
-          </a:p>
-          <a:p>
-            <a:pPr algn="ctr"/>
-            <a:r>
-              <a:rPr lang="es-ES" sz="900" i="1">
-                <a:solidFill>
-                  <a:srgbClr val="666666"/>
-                </a:solidFill>
-                <a:latin typeface="Arial" panose="020B0604020202020204" pitchFamily="34" charset="0"/>
-              </a:rPr>
-              <a:t>Autenticación en el cliente web</a:t>
-            </a:r>
-            <a:endParaRPr lang="en-US" sz="900" i="1">
-              <a:solidFill>
-                <a:srgbClr val="666666"/>
-              </a:solidFill>
-              <a:latin typeface="Arial" panose="020B0604020202020204" pitchFamily="34" charset="0"/>
-            </a:endParaRPr>
-          </a:p>
-        </p:txBody>
-      </p:sp>
+      </p:pic>
     </p:spTree>
   </p:cSld>
   <p:clrMapOvr>
@@ -29723,18 +28553,19 @@
           </a:p>
         </p:txBody>
       </p:sp>
-      <p:sp>
-        <p:nvSpPr>
-          <p:cNvPr id="2" name="CAPTURA PENDIENTE - Conversión realizada desde el cliente web">
-            <a:extLst>
-              <a:ext uri="{FF2B5EF4-FFF2-40B4-BE49-F238E27FC236}">
-                <a16:creationId xmlns:a16="http://schemas.microsoft.com/office/drawing/2014/main" id="{CF652FE7-A338-4840-BAF2-EB38435440B1}"/>
-              </a:ext>
-            </a:extLst>
-          </p:cNvPr>
-          <p:cNvSpPr/>
+      <p:pic>
+        <p:nvPicPr>
+          <p:cNvPr id="421" name="image127.png"/>
+          <p:cNvPicPr/>
           <p:nvPr/>
-        </p:nvSpPr>
+        </p:nvPicPr>
+        <p:blipFill>
+          <a:blip r:embed="rId3"/>
+          <a:srcRect/>
+          <a:stretch>
+            <a:fillRect/>
+          </a:stretch>
+        </p:blipFill>
         <p:spPr>
           <a:xfrm>
             <a:off x="3686896" y="2718547"/>
@@ -29743,68 +28574,13 @@
           <a:prstGeom prst="rect">
             <a:avLst/>
           </a:prstGeom>
-          <a:solidFill>
-            <a:srgbClr val="FFFFFF"/>
-          </a:solidFill>
-          <a:ln w="15875">
+          <a:ln w="12700">
             <a:solidFill>
-              <a:srgbClr val="D9D9D9"/>
+              <a:srgbClr val="CCCCCC"/>
             </a:solidFill>
           </a:ln>
         </p:spPr>
-        <p:style>
-          <a:lnRef idx="2">
-            <a:schemeClr val="accent1">
-              <a:shade val="50000"/>
-            </a:schemeClr>
-          </a:lnRef>
-          <a:fillRef idx="1">
-            <a:schemeClr val="accent1"/>
-          </a:fillRef>
-          <a:effectRef idx="0">
-            <a:schemeClr val="accent1"/>
-          </a:effectRef>
-          <a:fontRef idx="minor">
-            <a:schemeClr val="lt1"/>
-          </a:fontRef>
-        </p:style>
-        <p:txBody>
-          <a:bodyPr wrap="square" lIns="76200" tIns="38100" rIns="76200" bIns="38100" rtlCol="0" anchor="ctr">
-            <a:noAutofit/>
-          </a:bodyPr>
-          <a:lstStyle/>
-          <a:p>
-            <a:pPr algn="ctr"/>
-            <a:r>
-              <a:rPr lang="es-ES" sz="900" i="1">
-                <a:solidFill>
-                  <a:srgbClr val="666666"/>
-                </a:solidFill>
-                <a:latin typeface="Arial" panose="020B0604020202020204" pitchFamily="34" charset="0"/>
-              </a:rPr>
-              <a:t>CAPTURA PENDIENTE</a:t>
-            </a:r>
-          </a:p>
-          <a:p>
-            <a:pPr algn="ctr"/>
-            <a:r>
-              <a:rPr lang="es-ES" sz="900" i="1">
-                <a:solidFill>
-                  <a:srgbClr val="666666"/>
-                </a:solidFill>
-                <a:latin typeface="Arial" panose="020B0604020202020204" pitchFamily="34" charset="0"/>
-              </a:rPr>
-              <a:t>Conversión realizada desde el cliente web</a:t>
-            </a:r>
-            <a:endParaRPr lang="en-US" sz="900" i="1">
-              <a:solidFill>
-                <a:srgbClr val="666666"/>
-              </a:solidFill>
-              <a:latin typeface="Arial" panose="020B0604020202020204" pitchFamily="34" charset="0"/>
-            </a:endParaRPr>
-          </a:p>
-        </p:txBody>
-      </p:sp>
+      </p:pic>
     </p:spTree>
   </p:cSld>
   <p:clrMapOvr>
@@ -30496,18 +29272,19 @@
           </a:p>
         </p:txBody>
       </p:sp>
-      <p:sp>
-        <p:nvSpPr>
-          <p:cNvPr id="2" name="CAPTURA PENDIENTE - Configuración del proyecto y dependencia cliente">
-            <a:extLst>
-              <a:ext uri="{FF2B5EF4-FFF2-40B4-BE49-F238E27FC236}">
-                <a16:creationId xmlns:a16="http://schemas.microsoft.com/office/drawing/2014/main" id="{7FA02659-968B-436E-8575-1E22FA0ED2B1}"/>
-              </a:ext>
-            </a:extLst>
-          </p:cNvPr>
-          <p:cNvSpPr/>
+      <p:pic>
+        <p:nvPicPr>
+          <p:cNvPr id="430" name="image112.png"/>
+          <p:cNvPicPr/>
           <p:nvPr/>
-        </p:nvSpPr>
+        </p:nvPicPr>
+        <p:blipFill>
+          <a:blip r:embed="rId3"/>
+          <a:srcRect/>
+          <a:stretch>
+            <a:fillRect/>
+          </a:stretch>
+        </p:blipFill>
         <p:spPr>
           <a:xfrm>
             <a:off x="904275" y="5528800"/>
@@ -30516,80 +29293,26 @@
           <a:prstGeom prst="rect">
             <a:avLst/>
           </a:prstGeom>
-          <a:solidFill>
-            <a:srgbClr val="FFFFFF"/>
-          </a:solidFill>
-          <a:ln w="15875">
+          <a:ln w="12700">
             <a:solidFill>
-              <a:srgbClr val="D9D9D9"/>
+              <a:srgbClr val="CCCCCC"/>
             </a:solidFill>
           </a:ln>
         </p:spPr>
-        <p:style>
-          <a:lnRef idx="2">
-            <a:schemeClr val="accent1">
-              <a:shade val="50000"/>
-            </a:schemeClr>
-          </a:lnRef>
-          <a:fillRef idx="1">
-            <a:schemeClr val="accent1"/>
-          </a:fillRef>
-          <a:effectRef idx="0">
-            <a:schemeClr val="accent1"/>
-          </a:effectRef>
-          <a:fontRef idx="minor">
-            <a:schemeClr val="lt1"/>
-          </a:fontRef>
-        </p:style>
-        <p:txBody>
-          <a:bodyPr wrap="square" lIns="76200" tIns="38100" rIns="76200" bIns="38100" rtlCol="0" anchor="ctr">
-            <a:noAutofit/>
-          </a:bodyPr>
-          <a:lstStyle/>
-          <a:p>
-            <a:pPr algn="ctr"/>
-            <a:r>
-              <a:rPr lang="es-ES" sz="900" i="1">
-                <a:solidFill>
-                  <a:srgbClr val="666666"/>
-                </a:solidFill>
-                <a:latin typeface="Arial" panose="020B0604020202020204" pitchFamily="34" charset="0"/>
-              </a:rPr>
-              <a:t>CAPTURA PENDIENTE</a:t>
-            </a:r>
-          </a:p>
-          <a:p>
-            <a:pPr algn="ctr"/>
-            <a:r>
-              <a:rPr lang="es-ES" sz="900" i="1">
-                <a:solidFill>
-                  <a:srgbClr val="666666"/>
-                </a:solidFill>
-                <a:latin typeface="Arial" panose="020B0604020202020204" pitchFamily="34" charset="0"/>
-              </a:rPr>
-              <a:t>Configuración del proyecto y dependencia cliente</a:t>
-            </a:r>
-            <a:endParaRPr lang="en-US" sz="900" i="1">
-              <a:solidFill>
-                <a:srgbClr val="666666"/>
-              </a:solidFill>
-              <a:latin typeface="Arial" panose="020B0604020202020204" pitchFamily="34" charset="0"/>
-            </a:endParaRPr>
-          </a:p>
-        </p:txBody>
-      </p:sp>
-      <p:sp>
-        <p:nvSpPr>
-          <p:cNvPr id="3" name="CAPTURA PENDIENTE - Creación de actividad Android">
-            <a:extLst>
-              <a:ext uri="{FF2B5EF4-FFF2-40B4-BE49-F238E27FC236}">
-                <a16:creationId xmlns:a16="http://schemas.microsoft.com/office/drawing/2014/main" id="{41284340-73FC-4346-8B2A-67FE8EF1697E}"/>
-              </a:ext>
-            </a:extLst>
-          </p:cNvPr>
-          <p:cNvSpPr/>
+      </p:pic>
+      <p:pic>
+        <p:nvPicPr>
+          <p:cNvPr id="431" name="image113.png"/>
+          <p:cNvPicPr/>
           <p:nvPr/>
-        </p:nvSpPr>
+        </p:nvPicPr>
+        <p:blipFill>
+          <a:blip r:embed="rId4"/>
+          <a:srcRect/>
+          <a:stretch>
+            <a:fillRect/>
+          </a:stretch>
+        </p:blipFill>
         <p:spPr>
           <a:xfrm>
             <a:off x="5410937" y="4209124"/>
@@ -30598,80 +29321,26 @@
           <a:prstGeom prst="rect">
             <a:avLst/>
           </a:prstGeom>
-          <a:solidFill>
-            <a:srgbClr val="FFFFFF"/>
-          </a:solidFill>
-          <a:ln w="15875">
+          <a:ln w="12700">
             <a:solidFill>
-              <a:srgbClr val="D9D9D9"/>
+              <a:srgbClr val="CCCCCC"/>
             </a:solidFill>
           </a:ln>
         </p:spPr>
-        <p:style>
-          <a:lnRef idx="2">
-            <a:schemeClr val="accent1">
-              <a:shade val="50000"/>
-            </a:schemeClr>
-          </a:lnRef>
-          <a:fillRef idx="1">
-            <a:schemeClr val="accent1"/>
-          </a:fillRef>
-          <a:effectRef idx="0">
-            <a:schemeClr val="accent1"/>
-          </a:effectRef>
-          <a:fontRef idx="minor">
-            <a:schemeClr val="lt1"/>
-          </a:fontRef>
-        </p:style>
-        <p:txBody>
-          <a:bodyPr wrap="square" lIns="76200" tIns="38100" rIns="76200" bIns="38100" rtlCol="0" anchor="ctr">
-            <a:noAutofit/>
-          </a:bodyPr>
-          <a:lstStyle/>
-          <a:p>
-            <a:pPr algn="ctr"/>
-            <a:r>
-              <a:rPr lang="es-ES" sz="900" i="1">
-                <a:solidFill>
-                  <a:srgbClr val="666666"/>
-                </a:solidFill>
-                <a:latin typeface="Arial" panose="020B0604020202020204" pitchFamily="34" charset="0"/>
-              </a:rPr>
-              <a:t>CAPTURA PENDIENTE</a:t>
-            </a:r>
-          </a:p>
-          <a:p>
-            <a:pPr algn="ctr"/>
-            <a:r>
-              <a:rPr lang="es-ES" sz="900" i="1">
-                <a:solidFill>
-                  <a:srgbClr val="666666"/>
-                </a:solidFill>
-                <a:latin typeface="Arial" panose="020B0604020202020204" pitchFamily="34" charset="0"/>
-              </a:rPr>
-              <a:t>Creación de actividad Android</a:t>
-            </a:r>
-            <a:endParaRPr lang="en-US" sz="900" i="1">
-              <a:solidFill>
-                <a:srgbClr val="666666"/>
-              </a:solidFill>
-              <a:latin typeface="Arial" panose="020B0604020202020204" pitchFamily="34" charset="0"/>
-            </a:endParaRPr>
-          </a:p>
-        </p:txBody>
-      </p:sp>
-      <p:sp>
-        <p:nvSpPr>
-          <p:cNvPr id="4" name="CAPTURA PENDIENTE - Captura del módulo descrito en esta diapositiva">
-            <a:extLst>
-              <a:ext uri="{FF2B5EF4-FFF2-40B4-BE49-F238E27FC236}">
-                <a16:creationId xmlns:a16="http://schemas.microsoft.com/office/drawing/2014/main" id="{4C801D5B-CB78-4EE0-B2EB-3BF11E28CAE4}"/>
-              </a:ext>
-            </a:extLst>
-          </p:cNvPr>
-          <p:cNvSpPr/>
+      </p:pic>
+      <p:pic>
+        <p:nvPicPr>
+          <p:cNvPr id="432" name="image114.png"/>
+          <p:cNvPicPr/>
           <p:nvPr/>
-        </p:nvSpPr>
+        </p:nvPicPr>
+        <p:blipFill>
+          <a:blip r:embed="rId5"/>
+          <a:srcRect/>
+          <a:stretch>
+            <a:fillRect/>
+          </a:stretch>
+        </p:blipFill>
         <p:spPr>
           <a:xfrm>
             <a:off x="6418749" y="2402189"/>
@@ -30680,68 +29349,13 @@
           <a:prstGeom prst="rect">
             <a:avLst/>
           </a:prstGeom>
-          <a:solidFill>
-            <a:srgbClr val="FFFFFF"/>
-          </a:solidFill>
-          <a:ln w="15875">
+          <a:ln w="12700">
             <a:solidFill>
-              <a:srgbClr val="D9D9D9"/>
+              <a:srgbClr val="CCCCCC"/>
             </a:solidFill>
           </a:ln>
         </p:spPr>
-        <p:style>
-          <a:lnRef idx="2">
-            <a:schemeClr val="accent1">
-              <a:shade val="50000"/>
-            </a:schemeClr>
-          </a:lnRef>
-          <a:fillRef idx="1">
-            <a:schemeClr val="accent1"/>
-          </a:fillRef>
-          <a:effectRef idx="0">
-            <a:schemeClr val="accent1"/>
-          </a:effectRef>
-          <a:fontRef idx="minor">
-            <a:schemeClr val="lt1"/>
-          </a:fontRef>
-        </p:style>
-        <p:txBody>
-          <a:bodyPr wrap="square" lIns="76200" tIns="38100" rIns="76200" bIns="38100" rtlCol="0" anchor="ctr">
-            <a:noAutofit/>
-          </a:bodyPr>
-          <a:lstStyle/>
-          <a:p>
-            <a:pPr algn="ctr"/>
-            <a:r>
-              <a:rPr lang="es-ES" sz="900" i="1">
-                <a:solidFill>
-                  <a:srgbClr val="666666"/>
-                </a:solidFill>
-                <a:latin typeface="Arial" panose="020B0604020202020204" pitchFamily="34" charset="0"/>
-              </a:rPr>
-              <a:t>CAPTURA PENDIENTE</a:t>
-            </a:r>
-          </a:p>
-          <a:p>
-            <a:pPr algn="ctr"/>
-            <a:r>
-              <a:rPr lang="es-ES" sz="900" i="1">
-                <a:solidFill>
-                  <a:srgbClr val="666666"/>
-                </a:solidFill>
-                <a:latin typeface="Arial" panose="020B0604020202020204" pitchFamily="34" charset="0"/>
-              </a:rPr>
-              <a:t>Captura del módulo descrito en esta diapositiva</a:t>
-            </a:r>
-            <a:endParaRPr lang="en-US" sz="900" i="1">
-              <a:solidFill>
-                <a:srgbClr val="666666"/>
-              </a:solidFill>
-              <a:latin typeface="Arial" panose="020B0604020202020204" pitchFamily="34" charset="0"/>
-            </a:endParaRPr>
-          </a:p>
-        </p:txBody>
-      </p:sp>
+      </p:pic>
     </p:spTree>
   </p:cSld>
   <p:clrMapOvr>
@@ -31367,18 +29981,19 @@
           </a:p>
         </p:txBody>
       </p:sp>
-      <p:sp>
-        <p:nvSpPr>
-          <p:cNvPr id="2" name="CAPTURA PENDIENTE - Paquetes y estructura MVC de Android">
-            <a:extLst>
-              <a:ext uri="{FF2B5EF4-FFF2-40B4-BE49-F238E27FC236}">
-                <a16:creationId xmlns:a16="http://schemas.microsoft.com/office/drawing/2014/main" id="{36702E61-9B71-4603-BAD8-1C10AD2775F5}"/>
-              </a:ext>
-            </a:extLst>
-          </p:cNvPr>
-          <p:cNvSpPr/>
+      <p:pic>
+        <p:nvPicPr>
+          <p:cNvPr id="440" name="image113.png"/>
+          <p:cNvPicPr/>
           <p:nvPr/>
-        </p:nvSpPr>
+        </p:nvPicPr>
+        <p:blipFill>
+          <a:blip r:embed="rId3"/>
+          <a:srcRect/>
+          <a:stretch>
+            <a:fillRect/>
+          </a:stretch>
+        </p:blipFill>
         <p:spPr>
           <a:xfrm>
             <a:off x="4741537" y="2559253"/>
@@ -31387,68 +30002,13 @@
           <a:prstGeom prst="rect">
             <a:avLst/>
           </a:prstGeom>
-          <a:solidFill>
-            <a:srgbClr val="FFFFFF"/>
-          </a:solidFill>
-          <a:ln w="15875">
+          <a:ln w="12700">
             <a:solidFill>
-              <a:srgbClr val="D9D9D9"/>
+              <a:srgbClr val="CCCCCC"/>
             </a:solidFill>
           </a:ln>
         </p:spPr>
-        <p:style>
-          <a:lnRef idx="2">
-            <a:schemeClr val="accent1">
-              <a:shade val="50000"/>
-            </a:schemeClr>
-          </a:lnRef>
-          <a:fillRef idx="1">
-            <a:schemeClr val="accent1"/>
-          </a:fillRef>
-          <a:effectRef idx="0">
-            <a:schemeClr val="accent1"/>
-          </a:effectRef>
-          <a:fontRef idx="minor">
-            <a:schemeClr val="lt1"/>
-          </a:fontRef>
-        </p:style>
-        <p:txBody>
-          <a:bodyPr wrap="square" lIns="76200" tIns="38100" rIns="76200" bIns="38100" rtlCol="0" anchor="ctr">
-            <a:noAutofit/>
-          </a:bodyPr>
-          <a:lstStyle/>
-          <a:p>
-            <a:pPr algn="ctr"/>
-            <a:r>
-              <a:rPr lang="es-ES" sz="900" i="1">
-                <a:solidFill>
-                  <a:srgbClr val="666666"/>
-                </a:solidFill>
-                <a:latin typeface="Arial" panose="020B0604020202020204" pitchFamily="34" charset="0"/>
-              </a:rPr>
-              <a:t>CAPTURA PENDIENTE</a:t>
-            </a:r>
-          </a:p>
-          <a:p>
-            <a:pPr algn="ctr"/>
-            <a:r>
-              <a:rPr lang="es-ES" sz="900" i="1">
-                <a:solidFill>
-                  <a:srgbClr val="666666"/>
-                </a:solidFill>
-                <a:latin typeface="Arial" panose="020B0604020202020204" pitchFamily="34" charset="0"/>
-              </a:rPr>
-              <a:t>Paquetes y estructura MVC de Android</a:t>
-            </a:r>
-            <a:endParaRPr lang="en-US" sz="900" i="1">
-              <a:solidFill>
-                <a:srgbClr val="666666"/>
-              </a:solidFill>
-              <a:latin typeface="Arial" panose="020B0604020202020204" pitchFamily="34" charset="0"/>
-            </a:endParaRPr>
-          </a:p>
-        </p:txBody>
-      </p:sp>
+      </p:pic>
     </p:spTree>
   </p:cSld>
   <p:clrMapOvr>
@@ -32158,18 +30718,19 @@
           </a:p>
         </p:txBody>
       </p:sp>
-      <p:sp>
-        <p:nvSpPr>
-          <p:cNvPr id="2" name="CAPTURA PENDIENTE - Controlador de conversión móvil">
-            <a:extLst>
-              <a:ext uri="{FF2B5EF4-FFF2-40B4-BE49-F238E27FC236}">
-                <a16:creationId xmlns:a16="http://schemas.microsoft.com/office/drawing/2014/main" id="{760DE4C0-82E6-4314-AB2E-742463D86AE8}"/>
-              </a:ext>
-            </a:extLst>
-          </p:cNvPr>
-          <p:cNvSpPr/>
+      <p:pic>
+        <p:nvPicPr>
+          <p:cNvPr id="449" name="image114.png"/>
+          <p:cNvPicPr/>
           <p:nvPr/>
-        </p:nvSpPr>
+        </p:nvPicPr>
+        <p:blipFill>
+          <a:blip r:embed="rId3"/>
+          <a:srcRect/>
+          <a:stretch>
+            <a:fillRect/>
+          </a:stretch>
+        </p:blipFill>
         <p:spPr>
           <a:xfrm>
             <a:off x="4980331" y="3429000"/>
@@ -32178,80 +30739,26 @@
           <a:prstGeom prst="rect">
             <a:avLst/>
           </a:prstGeom>
-          <a:solidFill>
-            <a:srgbClr val="FFFFFF"/>
-          </a:solidFill>
-          <a:ln w="15875">
+          <a:ln w="12700">
             <a:solidFill>
-              <a:srgbClr val="D9D9D9"/>
+              <a:srgbClr val="CCCCCC"/>
             </a:solidFill>
           </a:ln>
         </p:spPr>
-        <p:style>
-          <a:lnRef idx="2">
-            <a:schemeClr val="accent1">
-              <a:shade val="50000"/>
-            </a:schemeClr>
-          </a:lnRef>
-          <a:fillRef idx="1">
-            <a:schemeClr val="accent1"/>
-          </a:fillRef>
-          <a:effectRef idx="0">
-            <a:schemeClr val="accent1"/>
-          </a:effectRef>
-          <a:fontRef idx="minor">
-            <a:schemeClr val="lt1"/>
-          </a:fontRef>
-        </p:style>
-        <p:txBody>
-          <a:bodyPr wrap="square" lIns="76200" tIns="38100" rIns="76200" bIns="38100" rtlCol="0" anchor="ctr">
-            <a:noAutofit/>
-          </a:bodyPr>
-          <a:lstStyle/>
-          <a:p>
-            <a:pPr algn="ctr"/>
-            <a:r>
-              <a:rPr lang="es-ES" sz="900" i="1">
-                <a:solidFill>
-                  <a:srgbClr val="666666"/>
-                </a:solidFill>
-                <a:latin typeface="Arial" panose="020B0604020202020204" pitchFamily="34" charset="0"/>
-              </a:rPr>
-              <a:t>CAPTURA PENDIENTE</a:t>
-            </a:r>
-          </a:p>
-          <a:p>
-            <a:pPr algn="ctr"/>
-            <a:r>
-              <a:rPr lang="es-ES" sz="900" i="1">
-                <a:solidFill>
-                  <a:srgbClr val="666666"/>
-                </a:solidFill>
-                <a:latin typeface="Arial" panose="020B0604020202020204" pitchFamily="34" charset="0"/>
-              </a:rPr>
-              <a:t>Controlador de conversión móvil</a:t>
-            </a:r>
-            <a:endParaRPr lang="en-US" sz="900" i="1">
-              <a:solidFill>
-                <a:srgbClr val="666666"/>
-              </a:solidFill>
-              <a:latin typeface="Arial" panose="020B0604020202020204" pitchFamily="34" charset="0"/>
-            </a:endParaRPr>
-          </a:p>
-        </p:txBody>
-      </p:sp>
-      <p:sp>
-        <p:nvSpPr>
-          <p:cNvPr id="4" name="CAPTURA PENDIENTE - Cliente SOAP/REST del móvil">
-            <a:extLst>
-              <a:ext uri="{FF2B5EF4-FFF2-40B4-BE49-F238E27FC236}">
-                <a16:creationId xmlns:a16="http://schemas.microsoft.com/office/drawing/2014/main" id="{BD4B1769-EB83-4114-B094-A3F8F5C58221}"/>
-              </a:ext>
-            </a:extLst>
-          </p:cNvPr>
-          <p:cNvSpPr/>
+      </p:pic>
+      <p:pic>
+        <p:nvPicPr>
+          <p:cNvPr id="450" name="image114.png"/>
+          <p:cNvPicPr/>
           <p:nvPr/>
-        </p:nvSpPr>
+        </p:nvPicPr>
+        <p:blipFill>
+          <a:blip r:embed="rId4"/>
+          <a:srcRect/>
+          <a:stretch>
+            <a:fillRect/>
+          </a:stretch>
+        </p:blipFill>
         <p:spPr>
           <a:xfrm>
             <a:off x="491075" y="3711388"/>
@@ -32260,62 +30767,13 @@
           <a:prstGeom prst="rect">
             <a:avLst/>
           </a:prstGeom>
-          <a:solidFill>
-            <a:srgbClr val="FFFFFF"/>
-          </a:solidFill>
-          <a:ln w="15875">
+          <a:ln w="12700">
             <a:solidFill>
-              <a:srgbClr val="D9D9D9"/>
+              <a:srgbClr val="CCCCCC"/>
             </a:solidFill>
           </a:ln>
         </p:spPr>
-        <p:style>
-          <a:lnRef idx="2">
-            <a:schemeClr val="accent1">
-              <a:shade val="50000"/>
-            </a:schemeClr>
-          </a:lnRef>
-          <a:fillRef idx="1">
-            <a:schemeClr val="accent1"/>
-          </a:fillRef>
-          <a:effectRef idx="0">
-            <a:schemeClr val="accent1"/>
-          </a:effectRef>
-          <a:fontRef idx="minor">
-            <a:schemeClr val="lt1"/>
-          </a:fontRef>
-        </p:style>
-        <p:txBody>
-          <a:bodyPr wrap="square" lIns="76200" tIns="38100" rIns="76200" bIns="38100" rtlCol="0" anchor="ctr">
-            <a:noAutofit/>
-          </a:bodyPr>
-          <a:lstStyle/>
-          <a:p>
-            <a:pPr algn="ctr"/>
-            <a:r>
-              <a:rPr lang="en-US" sz="900" i="1">
-                <a:solidFill>
-                  <a:srgbClr val="666666"/>
-                </a:solidFill>
-                <a:latin typeface="Arial" panose="020B0604020202020204" pitchFamily="34" charset="0"/>
-              </a:rPr>
-              <a:t>CAPTURA PENDIENTE</a:t>
-            </a:r>
-          </a:p>
-          <a:p>
-            <a:pPr algn="ctr"/>
-            <a:r>
-              <a:rPr lang="en-US" sz="900" i="1">
-                <a:solidFill>
-                  <a:srgbClr val="666666"/>
-                </a:solidFill>
-                <a:latin typeface="Arial" panose="020B0604020202020204" pitchFamily="34" charset="0"/>
-              </a:rPr>
-              <a:t>Cliente SOAP/REST del móvil</a:t>
-            </a:r>
-          </a:p>
-        </p:txBody>
-      </p:sp>
+      </p:pic>
     </p:spTree>
   </p:cSld>
   <p:clrMapOvr>
@@ -33025,18 +31483,19 @@
           </a:p>
         </p:txBody>
       </p:sp>
-      <p:sp>
-        <p:nvSpPr>
-          <p:cNvPr id="2" name="CAPTURA PENDIENTE - Pantalla móvil de conversión">
-            <a:extLst>
-              <a:ext uri="{FF2B5EF4-FFF2-40B4-BE49-F238E27FC236}">
-                <a16:creationId xmlns:a16="http://schemas.microsoft.com/office/drawing/2014/main" id="{285724F7-4293-4679-9704-747298B3B882}"/>
-              </a:ext>
-            </a:extLst>
-          </p:cNvPr>
-          <p:cNvSpPr/>
+      <p:pic>
+        <p:nvPicPr>
+          <p:cNvPr id="459" name="image130.png"/>
+          <p:cNvPicPr/>
           <p:nvPr/>
-        </p:nvSpPr>
+        </p:nvPicPr>
+        <p:blipFill>
+          <a:blip r:embed="rId3"/>
+          <a:srcRect/>
+          <a:stretch>
+            <a:fillRect/>
+          </a:stretch>
+        </p:blipFill>
         <p:spPr>
           <a:xfrm>
             <a:off x="5096586" y="3395466"/>
@@ -33045,80 +31504,26 @@
           <a:prstGeom prst="rect">
             <a:avLst/>
           </a:prstGeom>
-          <a:solidFill>
-            <a:srgbClr val="FFFFFF"/>
-          </a:solidFill>
-          <a:ln w="15875">
+          <a:ln w="12700">
             <a:solidFill>
-              <a:srgbClr val="D9D9D9"/>
+              <a:srgbClr val="CCCCCC"/>
             </a:solidFill>
           </a:ln>
         </p:spPr>
-        <p:style>
-          <a:lnRef idx="2">
-            <a:schemeClr val="accent1">
-              <a:shade val="50000"/>
-            </a:schemeClr>
-          </a:lnRef>
-          <a:fillRef idx="1">
-            <a:schemeClr val="accent1"/>
-          </a:fillRef>
-          <a:effectRef idx="0">
-            <a:schemeClr val="accent1"/>
-          </a:effectRef>
-          <a:fontRef idx="minor">
-            <a:schemeClr val="lt1"/>
-          </a:fontRef>
-        </p:style>
-        <p:txBody>
-          <a:bodyPr wrap="square" lIns="76200" tIns="38100" rIns="76200" bIns="38100" rtlCol="0" anchor="ctr">
-            <a:noAutofit/>
-          </a:bodyPr>
-          <a:lstStyle/>
-          <a:p>
-            <a:pPr algn="ctr"/>
-            <a:r>
-              <a:rPr lang="es-ES" sz="900" i="1">
-                <a:solidFill>
-                  <a:srgbClr val="666666"/>
-                </a:solidFill>
-                <a:latin typeface="Arial" panose="020B0604020202020204" pitchFamily="34" charset="0"/>
-              </a:rPr>
-              <a:t>CAPTURA PENDIENTE</a:t>
-            </a:r>
-          </a:p>
-          <a:p>
-            <a:pPr algn="ctr"/>
-            <a:r>
-              <a:rPr lang="es-ES" sz="900" i="1">
-                <a:solidFill>
-                  <a:srgbClr val="666666"/>
-                </a:solidFill>
-                <a:latin typeface="Arial" panose="020B0604020202020204" pitchFamily="34" charset="0"/>
-              </a:rPr>
-              <a:t>Pantalla móvil de conversión</a:t>
-            </a:r>
-            <a:endParaRPr lang="en-US" sz="900" i="1">
-              <a:solidFill>
-                <a:srgbClr val="666666"/>
-              </a:solidFill>
-              <a:latin typeface="Arial" panose="020B0604020202020204" pitchFamily="34" charset="0"/>
-            </a:endParaRPr>
-          </a:p>
-        </p:txBody>
-      </p:sp>
-      <p:sp>
-        <p:nvSpPr>
-          <p:cNvPr id="4" name="CAPTURA PENDIENTE - Pantalla móvil de inicio de sesión">
-            <a:extLst>
-              <a:ext uri="{FF2B5EF4-FFF2-40B4-BE49-F238E27FC236}">
-                <a16:creationId xmlns:a16="http://schemas.microsoft.com/office/drawing/2014/main" id="{04AF29B5-117D-4812-83CA-A17B8CAD3DD2}"/>
-              </a:ext>
-            </a:extLst>
-          </p:cNvPr>
-          <p:cNvSpPr/>
+      </p:pic>
+      <p:pic>
+        <p:nvPicPr>
+          <p:cNvPr id="460" name="image131.png"/>
+          <p:cNvPicPr/>
           <p:nvPr/>
-        </p:nvSpPr>
+        </p:nvPicPr>
+        <p:blipFill>
+          <a:blip r:embed="rId4"/>
+          <a:srcRect/>
+          <a:stretch>
+            <a:fillRect/>
+          </a:stretch>
+        </p:blipFill>
         <p:spPr>
           <a:xfrm>
             <a:off x="595071" y="3523400"/>
@@ -33127,68 +31532,13 @@
           <a:prstGeom prst="rect">
             <a:avLst/>
           </a:prstGeom>
-          <a:solidFill>
-            <a:srgbClr val="FFFFFF"/>
-          </a:solidFill>
-          <a:ln w="15875">
+          <a:ln w="12700">
             <a:solidFill>
-              <a:srgbClr val="D9D9D9"/>
+              <a:srgbClr val="CCCCCC"/>
             </a:solidFill>
           </a:ln>
         </p:spPr>
-        <p:style>
-          <a:lnRef idx="2">
-            <a:schemeClr val="accent1">
-              <a:shade val="50000"/>
-            </a:schemeClr>
-          </a:lnRef>
-          <a:fillRef idx="1">
-            <a:schemeClr val="accent1"/>
-          </a:fillRef>
-          <a:effectRef idx="0">
-            <a:schemeClr val="accent1"/>
-          </a:effectRef>
-          <a:fontRef idx="minor">
-            <a:schemeClr val="lt1"/>
-          </a:fontRef>
-        </p:style>
-        <p:txBody>
-          <a:bodyPr wrap="square" lIns="76200" tIns="38100" rIns="76200" bIns="38100" rtlCol="0" anchor="ctr">
-            <a:noAutofit/>
-          </a:bodyPr>
-          <a:lstStyle/>
-          <a:p>
-            <a:pPr algn="ctr"/>
-            <a:r>
-              <a:rPr lang="es-ES" sz="900" i="1">
-                <a:solidFill>
-                  <a:srgbClr val="666666"/>
-                </a:solidFill>
-                <a:latin typeface="Arial" panose="020B0604020202020204" pitchFamily="34" charset="0"/>
-              </a:rPr>
-              <a:t>CAPTURA PENDIENTE</a:t>
-            </a:r>
-          </a:p>
-          <a:p>
-            <a:pPr algn="ctr"/>
-            <a:r>
-              <a:rPr lang="es-ES" sz="900" i="1">
-                <a:solidFill>
-                  <a:srgbClr val="666666"/>
-                </a:solidFill>
-                <a:latin typeface="Arial" panose="020B0604020202020204" pitchFamily="34" charset="0"/>
-              </a:rPr>
-              <a:t>Pantalla móvil de inicio de sesión</a:t>
-            </a:r>
-            <a:endParaRPr lang="en-US" sz="900" i="1">
-              <a:solidFill>
-                <a:srgbClr val="666666"/>
-              </a:solidFill>
-              <a:latin typeface="Arial" panose="020B0604020202020204" pitchFamily="34" charset="0"/>
-            </a:endParaRPr>
-          </a:p>
-        </p:txBody>
-      </p:sp>
+      </p:pic>
     </p:spTree>
   </p:cSld>
   <p:clrMapOvr>
@@ -33791,18 +32141,19 @@
           </a:p>
         </p:txBody>
       </p:sp>
-      <p:sp>
-        <p:nvSpPr>
-          <p:cNvPr id="2" name="CAPTURA PENDIENTE - Ejecución en dispositivo físico">
-            <a:extLst>
-              <a:ext uri="{FF2B5EF4-FFF2-40B4-BE49-F238E27FC236}">
-                <a16:creationId xmlns:a16="http://schemas.microsoft.com/office/drawing/2014/main" id="{EFF9EA56-8E4A-4C81-B84A-E7CEC6A7482C}"/>
-              </a:ext>
-            </a:extLst>
-          </p:cNvPr>
-          <p:cNvSpPr/>
+      <p:pic>
+        <p:nvPicPr>
+          <p:cNvPr id="496" name="image131.png"/>
+          <p:cNvPicPr/>
           <p:nvPr/>
-        </p:nvSpPr>
+        </p:nvPicPr>
+        <p:blipFill>
+          <a:blip r:embed="rId3"/>
+          <a:srcRect/>
+          <a:stretch>
+            <a:fillRect/>
+          </a:stretch>
+        </p:blipFill>
         <p:spPr>
           <a:xfrm>
             <a:off x="4375360" y="3132224"/>
@@ -33811,80 +32162,26 @@
           <a:prstGeom prst="rect">
             <a:avLst/>
           </a:prstGeom>
-          <a:solidFill>
-            <a:srgbClr val="FFFFFF"/>
-          </a:solidFill>
-          <a:ln w="15875">
+          <a:ln w="12700">
             <a:solidFill>
-              <a:srgbClr val="D9D9D9"/>
+              <a:srgbClr val="CCCCCC"/>
             </a:solidFill>
           </a:ln>
         </p:spPr>
-        <p:style>
-          <a:lnRef idx="2">
-            <a:schemeClr val="accent1">
-              <a:shade val="50000"/>
-            </a:schemeClr>
-          </a:lnRef>
-          <a:fillRef idx="1">
-            <a:schemeClr val="accent1"/>
-          </a:fillRef>
-          <a:effectRef idx="0">
-            <a:schemeClr val="accent1"/>
-          </a:effectRef>
-          <a:fontRef idx="minor">
-            <a:schemeClr val="lt1"/>
-          </a:fontRef>
-        </p:style>
-        <p:txBody>
-          <a:bodyPr wrap="square" lIns="76200" tIns="38100" rIns="76200" bIns="38100" rtlCol="0" anchor="ctr">
-            <a:noAutofit/>
-          </a:bodyPr>
-          <a:lstStyle/>
-          <a:p>
-            <a:pPr algn="ctr"/>
-            <a:r>
-              <a:rPr lang="es-ES" sz="900" i="1">
-                <a:solidFill>
-                  <a:srgbClr val="666666"/>
-                </a:solidFill>
-                <a:latin typeface="Arial" panose="020B0604020202020204" pitchFamily="34" charset="0"/>
-              </a:rPr>
-              <a:t>CAPTURA PENDIENTE</a:t>
-            </a:r>
-          </a:p>
-          <a:p>
-            <a:pPr algn="ctr"/>
-            <a:r>
-              <a:rPr lang="es-ES" sz="900" i="1">
-                <a:solidFill>
-                  <a:srgbClr val="666666"/>
-                </a:solidFill>
-                <a:latin typeface="Arial" panose="020B0604020202020204" pitchFamily="34" charset="0"/>
-              </a:rPr>
-              <a:t>Ejecución en dispositivo físico</a:t>
-            </a:r>
-            <a:endParaRPr lang="en-US" sz="900" i="1">
-              <a:solidFill>
-                <a:srgbClr val="666666"/>
-              </a:solidFill>
-              <a:latin typeface="Arial" panose="020B0604020202020204" pitchFamily="34" charset="0"/>
-            </a:endParaRPr>
-          </a:p>
-        </p:txBody>
-      </p:sp>
-      <p:sp>
-        <p:nvSpPr>
-          <p:cNvPr id="3" name="CAPTURA PENDIENTE - Ejecución en emulador">
-            <a:extLst>
-              <a:ext uri="{FF2B5EF4-FFF2-40B4-BE49-F238E27FC236}">
-                <a16:creationId xmlns:a16="http://schemas.microsoft.com/office/drawing/2014/main" id="{6C8C1FDA-779D-4992-A82B-C2E2CFB93887}"/>
-              </a:ext>
-            </a:extLst>
-          </p:cNvPr>
-          <p:cNvSpPr/>
+      </p:pic>
+      <p:pic>
+        <p:nvPicPr>
+          <p:cNvPr id="497" name="image132.png"/>
+          <p:cNvPicPr/>
           <p:nvPr/>
-        </p:nvSpPr>
+        </p:nvPicPr>
+        <p:blipFill>
+          <a:blip r:embed="rId4"/>
+          <a:srcRect/>
+          <a:stretch>
+            <a:fillRect/>
+          </a:stretch>
+        </p:blipFill>
         <p:spPr>
           <a:xfrm>
             <a:off x="2107289" y="3132225"/>
@@ -33893,68 +32190,13 @@
           <a:prstGeom prst="rect">
             <a:avLst/>
           </a:prstGeom>
-          <a:solidFill>
-            <a:srgbClr val="FFFFFF"/>
-          </a:solidFill>
-          <a:ln w="15875">
+          <a:ln w="12700">
             <a:solidFill>
-              <a:srgbClr val="D9D9D9"/>
+              <a:srgbClr val="CCCCCC"/>
             </a:solidFill>
           </a:ln>
         </p:spPr>
-        <p:style>
-          <a:lnRef idx="2">
-            <a:schemeClr val="accent1">
-              <a:shade val="50000"/>
-            </a:schemeClr>
-          </a:lnRef>
-          <a:fillRef idx="1">
-            <a:schemeClr val="accent1"/>
-          </a:fillRef>
-          <a:effectRef idx="0">
-            <a:schemeClr val="accent1"/>
-          </a:effectRef>
-          <a:fontRef idx="minor">
-            <a:schemeClr val="lt1"/>
-          </a:fontRef>
-        </p:style>
-        <p:txBody>
-          <a:bodyPr wrap="square" lIns="76200" tIns="38100" rIns="76200" bIns="38100" rtlCol="0" anchor="ctr">
-            <a:noAutofit/>
-          </a:bodyPr>
-          <a:lstStyle/>
-          <a:p>
-            <a:pPr algn="ctr"/>
-            <a:r>
-              <a:rPr lang="es-ES" sz="900" i="1">
-                <a:solidFill>
-                  <a:srgbClr val="666666"/>
-                </a:solidFill>
-                <a:latin typeface="Arial" panose="020B0604020202020204" pitchFamily="34" charset="0"/>
-              </a:rPr>
-              <a:t>CAPTURA PENDIENTE</a:t>
-            </a:r>
-          </a:p>
-          <a:p>
-            <a:pPr algn="ctr"/>
-            <a:r>
-              <a:rPr lang="es-ES" sz="900" i="1">
-                <a:solidFill>
-                  <a:srgbClr val="666666"/>
-                </a:solidFill>
-                <a:latin typeface="Arial" panose="020B0604020202020204" pitchFamily="34" charset="0"/>
-              </a:rPr>
-              <a:t>Ejecución en emulador</a:t>
-            </a:r>
-            <a:endParaRPr lang="en-US" sz="900" i="1">
-              <a:solidFill>
-                <a:srgbClr val="666666"/>
-              </a:solidFill>
-              <a:latin typeface="Arial" panose="020B0604020202020204" pitchFamily="34" charset="0"/>
-            </a:endParaRPr>
-          </a:p>
-        </p:txBody>
-      </p:sp>
+      </p:pic>
     </p:spTree>
   </p:cSld>
   <p:clrMapOvr>
@@ -36573,18 +34815,19 @@
           </a:p>
         </p:txBody>
       </p:sp>
-      <p:sp>
-        <p:nvSpPr>
-          <p:cNvPr id="2" name="CAPTURA PENDIENTE - Estructura inicial del servidor">
-            <a:extLst>
-              <a:ext uri="{FF2B5EF4-FFF2-40B4-BE49-F238E27FC236}">
-                <a16:creationId xmlns:a16="http://schemas.microsoft.com/office/drawing/2014/main" id="{8F4CF77D-59BB-4DD6-9BE8-8A7DEA0F6D70}"/>
-              </a:ext>
-            </a:extLst>
-          </p:cNvPr>
-          <p:cNvSpPr/>
+      <p:pic>
+        <p:nvPicPr>
+          <p:cNvPr id="124" name="image53.png"/>
+          <p:cNvPicPr/>
           <p:nvPr/>
-        </p:nvSpPr>
+        </p:nvPicPr>
+        <p:blipFill>
+          <a:blip r:embed="rId3"/>
+          <a:srcRect/>
+          <a:stretch>
+            <a:fillRect/>
+          </a:stretch>
+        </p:blipFill>
         <p:spPr>
           <a:xfrm>
             <a:off x="6096000" y="3709191"/>
@@ -36593,80 +34836,26 @@
           <a:prstGeom prst="rect">
             <a:avLst/>
           </a:prstGeom>
-          <a:solidFill>
-            <a:srgbClr val="FFFFFF"/>
-          </a:solidFill>
-          <a:ln w="15875">
+          <a:ln w="12700">
             <a:solidFill>
-              <a:srgbClr val="D9D9D9"/>
+              <a:srgbClr val="CCCCCC"/>
             </a:solidFill>
           </a:ln>
         </p:spPr>
-        <p:style>
-          <a:lnRef idx="2">
-            <a:schemeClr val="accent1">
-              <a:shade val="50000"/>
-            </a:schemeClr>
-          </a:lnRef>
-          <a:fillRef idx="1">
-            <a:schemeClr val="accent1"/>
-          </a:fillRef>
-          <a:effectRef idx="0">
-            <a:schemeClr val="accent1"/>
-          </a:effectRef>
-          <a:fontRef idx="minor">
-            <a:schemeClr val="lt1"/>
-          </a:fontRef>
-        </p:style>
-        <p:txBody>
-          <a:bodyPr wrap="square" lIns="76200" tIns="38100" rIns="76200" bIns="38100" rtlCol="0" anchor="ctr">
-            <a:noAutofit/>
-          </a:bodyPr>
-          <a:lstStyle/>
-          <a:p>
-            <a:pPr algn="ctr"/>
-            <a:r>
-              <a:rPr lang="es-ES" sz="900" i="1">
-                <a:solidFill>
-                  <a:srgbClr val="666666"/>
-                </a:solidFill>
-                <a:latin typeface="Arial" panose="020B0604020202020204" pitchFamily="34" charset="0"/>
-              </a:rPr>
-              <a:t>CAPTURA PENDIENTE</a:t>
-            </a:r>
-          </a:p>
-          <a:p>
-            <a:pPr algn="ctr"/>
-            <a:r>
-              <a:rPr lang="es-ES" sz="900" i="1">
-                <a:solidFill>
-                  <a:srgbClr val="666666"/>
-                </a:solidFill>
-                <a:latin typeface="Arial" panose="020B0604020202020204" pitchFamily="34" charset="0"/>
-              </a:rPr>
-              <a:t>Estructura inicial del servidor</a:t>
-            </a:r>
-            <a:endParaRPr lang="en-US" sz="900" i="1">
-              <a:solidFill>
-                <a:srgbClr val="666666"/>
-              </a:solidFill>
-              <a:latin typeface="Arial" panose="020B0604020202020204" pitchFamily="34" charset="0"/>
-            </a:endParaRPr>
-          </a:p>
-        </p:txBody>
-      </p:sp>
-      <p:sp>
-        <p:nvSpPr>
-          <p:cNvPr id="3" name="CAPTURA PENDIENTE - Ajustes del endpoint y dependencias">
-            <a:extLst>
-              <a:ext uri="{FF2B5EF4-FFF2-40B4-BE49-F238E27FC236}">
-                <a16:creationId xmlns:a16="http://schemas.microsoft.com/office/drawing/2014/main" id="{C2B37573-DD7F-4CE8-A0E8-5D433887D606}"/>
-              </a:ext>
-            </a:extLst>
-          </p:cNvPr>
-          <p:cNvSpPr/>
+      </p:pic>
+      <p:pic>
+        <p:nvPicPr>
+          <p:cNvPr id="125" name="image54.png"/>
+          <p:cNvPicPr/>
           <p:nvPr/>
-        </p:nvSpPr>
+        </p:nvPicPr>
+        <p:blipFill>
+          <a:blip r:embed="rId4"/>
+          <a:srcRect/>
+          <a:stretch>
+            <a:fillRect/>
+          </a:stretch>
+        </p:blipFill>
         <p:spPr>
           <a:xfrm>
             <a:off x="2953500" y="3716772"/>
@@ -36675,80 +34864,26 @@
           <a:prstGeom prst="rect">
             <a:avLst/>
           </a:prstGeom>
-          <a:solidFill>
-            <a:srgbClr val="FFFFFF"/>
-          </a:solidFill>
-          <a:ln w="15875">
+          <a:ln w="12700">
             <a:solidFill>
-              <a:srgbClr val="D9D9D9"/>
+              <a:srgbClr val="CCCCCC"/>
             </a:solidFill>
           </a:ln>
         </p:spPr>
-        <p:style>
-          <a:lnRef idx="2">
-            <a:schemeClr val="accent1">
-              <a:shade val="50000"/>
-            </a:schemeClr>
-          </a:lnRef>
-          <a:fillRef idx="1">
-            <a:schemeClr val="accent1"/>
-          </a:fillRef>
-          <a:effectRef idx="0">
-            <a:schemeClr val="accent1"/>
-          </a:effectRef>
-          <a:fontRef idx="minor">
-            <a:schemeClr val="lt1"/>
-          </a:fontRef>
-        </p:style>
-        <p:txBody>
-          <a:bodyPr wrap="square" lIns="76200" tIns="38100" rIns="76200" bIns="38100" rtlCol="0" anchor="ctr">
-            <a:noAutofit/>
-          </a:bodyPr>
-          <a:lstStyle/>
-          <a:p>
-            <a:pPr algn="ctr"/>
-            <a:r>
-              <a:rPr lang="es-ES" sz="900" i="1">
-                <a:solidFill>
-                  <a:srgbClr val="666666"/>
-                </a:solidFill>
-                <a:latin typeface="Arial" panose="020B0604020202020204" pitchFamily="34" charset="0"/>
-              </a:rPr>
-              <a:t>CAPTURA PENDIENTE</a:t>
-            </a:r>
-          </a:p>
-          <a:p>
-            <a:pPr algn="ctr"/>
-            <a:r>
-              <a:rPr lang="es-ES" sz="900" i="1">
-                <a:solidFill>
-                  <a:srgbClr val="666666"/>
-                </a:solidFill>
-                <a:latin typeface="Arial" panose="020B0604020202020204" pitchFamily="34" charset="0"/>
-              </a:rPr>
-              <a:t>Ajustes del endpoint y dependencias</a:t>
-            </a:r>
-            <a:endParaRPr lang="en-US" sz="900" i="1">
-              <a:solidFill>
-                <a:srgbClr val="666666"/>
-              </a:solidFill>
-              <a:latin typeface="Arial" panose="020B0604020202020204" pitchFamily="34" charset="0"/>
-            </a:endParaRPr>
-          </a:p>
-        </p:txBody>
-      </p:sp>
-      <p:sp>
-        <p:nvSpPr>
-          <p:cNvPr id="4" name="CAPTURA PENDIENTE - Proyecto Maven y configuración del servidor">
-            <a:extLst>
-              <a:ext uri="{FF2B5EF4-FFF2-40B4-BE49-F238E27FC236}">
-                <a16:creationId xmlns:a16="http://schemas.microsoft.com/office/drawing/2014/main" id="{493BDDFD-617A-44F4-8FC8-D380D1BF3B86}"/>
-              </a:ext>
-            </a:extLst>
-          </p:cNvPr>
-          <p:cNvSpPr/>
+      </p:pic>
+      <p:pic>
+        <p:nvPicPr>
+          <p:cNvPr id="126" name="image55.png"/>
+          <p:cNvPicPr/>
           <p:nvPr/>
-        </p:nvSpPr>
+        </p:nvPicPr>
+        <p:blipFill>
+          <a:blip r:embed="rId5"/>
+          <a:srcRect/>
+          <a:stretch>
+            <a:fillRect/>
+          </a:stretch>
+        </p:blipFill>
         <p:spPr>
           <a:xfrm>
             <a:off x="234986" y="3724354"/>
@@ -36757,68 +34892,13 @@
           <a:prstGeom prst="rect">
             <a:avLst/>
           </a:prstGeom>
-          <a:solidFill>
-            <a:srgbClr val="FFFFFF"/>
-          </a:solidFill>
-          <a:ln w="15875">
+          <a:ln w="12700">
             <a:solidFill>
-              <a:srgbClr val="D9D9D9"/>
+              <a:srgbClr val="CCCCCC"/>
             </a:solidFill>
           </a:ln>
         </p:spPr>
-        <p:style>
-          <a:lnRef idx="2">
-            <a:schemeClr val="accent1">
-              <a:shade val="50000"/>
-            </a:schemeClr>
-          </a:lnRef>
-          <a:fillRef idx="1">
-            <a:schemeClr val="accent1"/>
-          </a:fillRef>
-          <a:effectRef idx="0">
-            <a:schemeClr val="accent1"/>
-          </a:effectRef>
-          <a:fontRef idx="minor">
-            <a:schemeClr val="lt1"/>
-          </a:fontRef>
-        </p:style>
-        <p:txBody>
-          <a:bodyPr wrap="square" lIns="76200" tIns="38100" rIns="76200" bIns="38100" rtlCol="0" anchor="ctr">
-            <a:noAutofit/>
-          </a:bodyPr>
-          <a:lstStyle/>
-          <a:p>
-            <a:pPr algn="ctr"/>
-            <a:r>
-              <a:rPr lang="es-ES" sz="900" i="1">
-                <a:solidFill>
-                  <a:srgbClr val="666666"/>
-                </a:solidFill>
-                <a:latin typeface="Arial" panose="020B0604020202020204" pitchFamily="34" charset="0"/>
-              </a:rPr>
-              <a:t>CAPTURA PENDIENTE</a:t>
-            </a:r>
-          </a:p>
-          <a:p>
-            <a:pPr algn="ctr"/>
-            <a:r>
-              <a:rPr lang="es-ES" sz="900" i="1">
-                <a:solidFill>
-                  <a:srgbClr val="666666"/>
-                </a:solidFill>
-                <a:latin typeface="Arial" panose="020B0604020202020204" pitchFamily="34" charset="0"/>
-              </a:rPr>
-              <a:t>Proyecto Maven y configuración del servidor</a:t>
-            </a:r>
-            <a:endParaRPr lang="en-US" sz="900" i="1">
-              <a:solidFill>
-                <a:srgbClr val="666666"/>
-              </a:solidFill>
-              <a:latin typeface="Arial" panose="020B0604020202020204" pitchFamily="34" charset="0"/>
-            </a:endParaRPr>
-          </a:p>
-        </p:txBody>
-      </p:sp>
+      </p:pic>
     </p:spTree>
   </p:cSld>
   <p:clrMapOvr>
@@ -37489,18 +35569,19 @@
           </a:p>
         </p:txBody>
       </p:sp>
-      <p:sp>
-        <p:nvSpPr>
-          <p:cNvPr id="2" name="CAPTURA PENDIENTE - Configuración de recursos y formato de respuesta">
-            <a:extLst>
-              <a:ext uri="{FF2B5EF4-FFF2-40B4-BE49-F238E27FC236}">
-                <a16:creationId xmlns:a16="http://schemas.microsoft.com/office/drawing/2014/main" id="{D46C417E-63B1-4351-91FB-17167D2A159B}"/>
-              </a:ext>
-            </a:extLst>
-          </p:cNvPr>
-          <p:cNvSpPr/>
+      <p:pic>
+        <p:nvPicPr>
+          <p:cNvPr id="142" name="image56.png"/>
+          <p:cNvPicPr/>
           <p:nvPr/>
-        </p:nvSpPr>
+        </p:nvPicPr>
+        <p:blipFill>
+          <a:blip r:embed="rId3"/>
+          <a:srcRect/>
+          <a:stretch>
+            <a:fillRect/>
+          </a:stretch>
+        </p:blipFill>
         <p:spPr>
           <a:xfrm>
             <a:off x="3174120" y="3429000"/>
@@ -37509,80 +35590,26 @@
           <a:prstGeom prst="rect">
             <a:avLst/>
           </a:prstGeom>
-          <a:solidFill>
-            <a:srgbClr val="FFFFFF"/>
-          </a:solidFill>
-          <a:ln w="15875">
+          <a:ln w="12700">
             <a:solidFill>
-              <a:srgbClr val="D9D9D9"/>
+              <a:srgbClr val="CCCCCC"/>
             </a:solidFill>
           </a:ln>
         </p:spPr>
-        <p:style>
-          <a:lnRef idx="2">
-            <a:schemeClr val="accent1">
-              <a:shade val="50000"/>
-            </a:schemeClr>
-          </a:lnRef>
-          <a:fillRef idx="1">
-            <a:schemeClr val="accent1"/>
-          </a:fillRef>
-          <a:effectRef idx="0">
-            <a:schemeClr val="accent1"/>
-          </a:effectRef>
-          <a:fontRef idx="minor">
-            <a:schemeClr val="lt1"/>
-          </a:fontRef>
-        </p:style>
-        <p:txBody>
-          <a:bodyPr wrap="square" lIns="76200" tIns="38100" rIns="76200" bIns="38100" rtlCol="0" anchor="ctr">
-            <a:noAutofit/>
-          </a:bodyPr>
-          <a:lstStyle/>
-          <a:p>
-            <a:pPr algn="ctr"/>
-            <a:r>
-              <a:rPr lang="es-ES" sz="900" i="1">
-                <a:solidFill>
-                  <a:srgbClr val="666666"/>
-                </a:solidFill>
-                <a:latin typeface="Arial" panose="020B0604020202020204" pitchFamily="34" charset="0"/>
-              </a:rPr>
-              <a:t>CAPTURA PENDIENTE</a:t>
-            </a:r>
-          </a:p>
-          <a:p>
-            <a:pPr algn="ctr"/>
-            <a:r>
-              <a:rPr lang="es-ES" sz="900" i="1">
-                <a:solidFill>
-                  <a:srgbClr val="666666"/>
-                </a:solidFill>
-                <a:latin typeface="Arial" panose="020B0604020202020204" pitchFamily="34" charset="0"/>
-              </a:rPr>
-              <a:t>Configuración de recursos y formato de respuesta</a:t>
-            </a:r>
-            <a:endParaRPr lang="en-US" sz="900" i="1">
-              <a:solidFill>
-                <a:srgbClr val="666666"/>
-              </a:solidFill>
-              <a:latin typeface="Arial" panose="020B0604020202020204" pitchFamily="34" charset="0"/>
-            </a:endParaRPr>
-          </a:p>
-        </p:txBody>
-      </p:sp>
-      <p:sp>
-        <p:nvSpPr>
-          <p:cNvPr id="4" name="CAPTURA PENDIENTE - Dependencias de servicios SOAP/REST">
-            <a:extLst>
-              <a:ext uri="{FF2B5EF4-FFF2-40B4-BE49-F238E27FC236}">
-                <a16:creationId xmlns:a16="http://schemas.microsoft.com/office/drawing/2014/main" id="{08E533D8-CA82-48EB-A318-4D404FD2F869}"/>
-              </a:ext>
-            </a:extLst>
-          </p:cNvPr>
-          <p:cNvSpPr/>
+      </p:pic>
+      <p:pic>
+        <p:nvPicPr>
+          <p:cNvPr id="143" name="image57.png"/>
+          <p:cNvPicPr/>
           <p:nvPr/>
-        </p:nvSpPr>
+        </p:nvPicPr>
+        <p:blipFill>
+          <a:blip r:embed="rId4"/>
+          <a:srcRect/>
+          <a:stretch>
+            <a:fillRect/>
+          </a:stretch>
+        </p:blipFill>
         <p:spPr>
           <a:xfrm>
             <a:off x="916342" y="3401152"/>
@@ -37591,62 +35618,13 @@
           <a:prstGeom prst="rect">
             <a:avLst/>
           </a:prstGeom>
-          <a:solidFill>
-            <a:srgbClr val="FFFFFF"/>
-          </a:solidFill>
-          <a:ln w="15875">
+          <a:ln w="12700">
             <a:solidFill>
-              <a:srgbClr val="D9D9D9"/>
+              <a:srgbClr val="CCCCCC"/>
             </a:solidFill>
           </a:ln>
         </p:spPr>
-        <p:style>
-          <a:lnRef idx="2">
-            <a:schemeClr val="accent1">
-              <a:shade val="50000"/>
-            </a:schemeClr>
-          </a:lnRef>
-          <a:fillRef idx="1">
-            <a:schemeClr val="accent1"/>
-          </a:fillRef>
-          <a:effectRef idx="0">
-            <a:schemeClr val="accent1"/>
-          </a:effectRef>
-          <a:fontRef idx="minor">
-            <a:schemeClr val="lt1"/>
-          </a:fontRef>
-        </p:style>
-        <p:txBody>
-          <a:bodyPr wrap="square" lIns="76200" tIns="38100" rIns="76200" bIns="38100" rtlCol="0" anchor="ctr">
-            <a:noAutofit/>
-          </a:bodyPr>
-          <a:lstStyle/>
-          <a:p>
-            <a:pPr algn="ctr"/>
-            <a:r>
-              <a:rPr lang="en-US" sz="900" i="1">
-                <a:solidFill>
-                  <a:srgbClr val="666666"/>
-                </a:solidFill>
-                <a:latin typeface="Arial" panose="020B0604020202020204" pitchFamily="34" charset="0"/>
-              </a:rPr>
-              <a:t>CAPTURA PENDIENTE</a:t>
-            </a:r>
-          </a:p>
-          <a:p>
-            <a:pPr algn="ctr"/>
-            <a:r>
-              <a:rPr lang="en-US" sz="900" i="1">
-                <a:solidFill>
-                  <a:srgbClr val="666666"/>
-                </a:solidFill>
-                <a:latin typeface="Arial" panose="020B0604020202020204" pitchFamily="34" charset="0"/>
-              </a:rPr>
-              <a:t>Dependencias de servicios SOAP/REST</a:t>
-            </a:r>
-          </a:p>
-        </p:txBody>
-      </p:sp>
+      </p:pic>
     </p:spTree>
   </p:cSld>
   <p:clrMapOvr>
@@ -38317,18 +36295,19 @@
           </a:p>
         </p:txBody>
       </p:sp>
-      <p:sp>
-        <p:nvSpPr>
-          <p:cNvPr id="2" name="CAPTURA PENDIENTE - Paquetes y componentes del servidor">
-            <a:extLst>
-              <a:ext uri="{FF2B5EF4-FFF2-40B4-BE49-F238E27FC236}">
-                <a16:creationId xmlns:a16="http://schemas.microsoft.com/office/drawing/2014/main" id="{D5A955C8-73DF-4A43-96ED-5C495A39CF5E}"/>
-              </a:ext>
-            </a:extLst>
-          </p:cNvPr>
-          <p:cNvSpPr/>
+      <p:pic>
+        <p:nvPicPr>
+          <p:cNvPr id="151" name="image58.png"/>
+          <p:cNvPicPr/>
           <p:nvPr/>
-        </p:nvSpPr>
+        </p:nvPicPr>
+        <p:blipFill>
+          <a:blip r:embed="rId3"/>
+          <a:srcRect/>
+          <a:stretch>
+            <a:fillRect/>
+          </a:stretch>
+        </p:blipFill>
         <p:spPr>
           <a:xfrm>
             <a:off x="5749937" y="2870106"/>
@@ -38337,68 +36316,13 @@
           <a:prstGeom prst="rect">
             <a:avLst/>
           </a:prstGeom>
-          <a:solidFill>
-            <a:srgbClr val="FFFFFF"/>
-          </a:solidFill>
-          <a:ln w="15875">
+          <a:ln w="12700">
             <a:solidFill>
-              <a:srgbClr val="D9D9D9"/>
+              <a:srgbClr val="CCCCCC"/>
             </a:solidFill>
           </a:ln>
         </p:spPr>
-        <p:style>
-          <a:lnRef idx="2">
-            <a:schemeClr val="accent1">
-              <a:shade val="50000"/>
-            </a:schemeClr>
-          </a:lnRef>
-          <a:fillRef idx="1">
-            <a:schemeClr val="accent1"/>
-          </a:fillRef>
-          <a:effectRef idx="0">
-            <a:schemeClr val="accent1"/>
-          </a:effectRef>
-          <a:fontRef idx="minor">
-            <a:schemeClr val="lt1"/>
-          </a:fontRef>
-        </p:style>
-        <p:txBody>
-          <a:bodyPr wrap="square" lIns="76200" tIns="38100" rIns="76200" bIns="38100" rtlCol="0" anchor="ctr">
-            <a:noAutofit/>
-          </a:bodyPr>
-          <a:lstStyle/>
-          <a:p>
-            <a:pPr algn="ctr"/>
-            <a:r>
-              <a:rPr lang="es-ES" sz="900" i="1">
-                <a:solidFill>
-                  <a:srgbClr val="666666"/>
-                </a:solidFill>
-                <a:latin typeface="Arial" panose="020B0604020202020204" pitchFamily="34" charset="0"/>
-              </a:rPr>
-              <a:t>CAPTURA PENDIENTE</a:t>
-            </a:r>
-          </a:p>
-          <a:p>
-            <a:pPr algn="ctr"/>
-            <a:r>
-              <a:rPr lang="es-ES" sz="900" i="1">
-                <a:solidFill>
-                  <a:srgbClr val="666666"/>
-                </a:solidFill>
-                <a:latin typeface="Arial" panose="020B0604020202020204" pitchFamily="34" charset="0"/>
-              </a:rPr>
-              <a:t>Paquetes y componentes del servidor</a:t>
-            </a:r>
-            <a:endParaRPr lang="en-US" sz="900" i="1">
-              <a:solidFill>
-                <a:srgbClr val="666666"/>
-              </a:solidFill>
-              <a:latin typeface="Arial" panose="020B0604020202020204" pitchFamily="34" charset="0"/>
-            </a:endParaRPr>
-          </a:p>
-        </p:txBody>
-      </p:sp>
+      </p:pic>
     </p:spTree>
   </p:cSld>
   <p:clrMapOvr>
@@ -39065,18 +36989,19 @@
           </a:p>
         </p:txBody>
       </p:sp>
-      <p:sp>
-        <p:nvSpPr>
-          <p:cNvPr id="2" name="CAPTURA PENDIENTE - Código de publicación o registro de recursos">
-            <a:extLst>
-              <a:ext uri="{FF2B5EF4-FFF2-40B4-BE49-F238E27FC236}">
-                <a16:creationId xmlns:a16="http://schemas.microsoft.com/office/drawing/2014/main" id="{B7CF14C7-A1FB-46CD-9B06-2501C6854F36}"/>
-              </a:ext>
-            </a:extLst>
-          </p:cNvPr>
-          <p:cNvSpPr/>
+      <p:pic>
+        <p:nvPicPr>
+          <p:cNvPr id="167" name="image59.png"/>
+          <p:cNvPicPr/>
           <p:nvPr/>
-        </p:nvSpPr>
+        </p:nvPicPr>
+        <p:blipFill>
+          <a:blip r:embed="rId3"/>
+          <a:srcRect/>
+          <a:stretch>
+            <a:fillRect/>
+          </a:stretch>
+        </p:blipFill>
         <p:spPr>
           <a:xfrm>
             <a:off x="3875414" y="2817286"/>
@@ -39085,62 +37010,13 @@
           <a:prstGeom prst="rect">
             <a:avLst/>
           </a:prstGeom>
-          <a:solidFill>
-            <a:srgbClr val="FFFFFF"/>
-          </a:solidFill>
-          <a:ln w="15875">
+          <a:ln w="12700">
             <a:solidFill>
-              <a:srgbClr val="D9D9D9"/>
+              <a:srgbClr val="CCCCCC"/>
             </a:solidFill>
           </a:ln>
         </p:spPr>
-        <p:style>
-          <a:lnRef idx="2">
-            <a:schemeClr val="accent1">
-              <a:shade val="50000"/>
-            </a:schemeClr>
-          </a:lnRef>
-          <a:fillRef idx="1">
-            <a:schemeClr val="accent1"/>
-          </a:fillRef>
-          <a:effectRef idx="0">
-            <a:schemeClr val="accent1"/>
-          </a:effectRef>
-          <a:fontRef idx="minor">
-            <a:schemeClr val="lt1"/>
-          </a:fontRef>
-        </p:style>
-        <p:txBody>
-          <a:bodyPr wrap="square" lIns="76200" tIns="38100" rIns="76200" bIns="38100" rtlCol="0" anchor="ctr">
-            <a:noAutofit/>
-          </a:bodyPr>
-          <a:lstStyle/>
-          <a:p>
-            <a:pPr algn="ctr"/>
-            <a:r>
-              <a:rPr lang="en-US" sz="900" i="1">
-                <a:solidFill>
-                  <a:srgbClr val="666666"/>
-                </a:solidFill>
-                <a:latin typeface="Arial" panose="020B0604020202020204" pitchFamily="34" charset="0"/>
-              </a:rPr>
-              <a:t>CAPTURA PENDIENTE</a:t>
-            </a:r>
-          </a:p>
-          <a:p>
-            <a:pPr algn="ctr"/>
-            <a:r>
-              <a:rPr lang="en-US" sz="900" i="1">
-                <a:solidFill>
-                  <a:srgbClr val="666666"/>
-                </a:solidFill>
-                <a:latin typeface="Arial" panose="020B0604020202020204" pitchFamily="34" charset="0"/>
-              </a:rPr>
-              <a:t>Código de publicación o registro de recursos</a:t>
-            </a:r>
-          </a:p>
-        </p:txBody>
-      </p:sp>
+      </p:pic>
     </p:spTree>
   </p:cSld>
   <p:clrMapOvr>
@@ -39742,18 +37618,19 @@
           </a:p>
         </p:txBody>
       </p:sp>
-      <p:sp>
-        <p:nvSpPr>
-          <p:cNvPr id="2" name="CAPTURA PENDIENTE - Respuesta del servicio">
-            <a:extLst>
-              <a:ext uri="{FF2B5EF4-FFF2-40B4-BE49-F238E27FC236}">
-                <a16:creationId xmlns:a16="http://schemas.microsoft.com/office/drawing/2014/main" id="{E9114EA8-A636-4E5D-9078-2EE4448E41EF}"/>
-              </a:ext>
-            </a:extLst>
-          </p:cNvPr>
-          <p:cNvSpPr/>
+      <p:pic>
+        <p:nvPicPr>
+          <p:cNvPr id="191" name="image64.png"/>
+          <p:cNvPicPr/>
           <p:nvPr/>
-        </p:nvSpPr>
+        </p:nvPicPr>
+        <p:blipFill>
+          <a:blip r:embed="rId3"/>
+          <a:srcRect/>
+          <a:stretch>
+            <a:fillRect/>
+          </a:stretch>
+        </p:blipFill>
         <p:spPr>
           <a:xfrm>
             <a:off x="5818100" y="4415104"/>
@@ -39762,80 +37639,26 @@
           <a:prstGeom prst="rect">
             <a:avLst/>
           </a:prstGeom>
-          <a:solidFill>
-            <a:srgbClr val="FFFFFF"/>
-          </a:solidFill>
-          <a:ln w="15875">
+          <a:ln w="12700">
             <a:solidFill>
-              <a:srgbClr val="D9D9D9"/>
+              <a:srgbClr val="CCCCCC"/>
             </a:solidFill>
           </a:ln>
         </p:spPr>
-        <p:style>
-          <a:lnRef idx="2">
-            <a:schemeClr val="accent1">
-              <a:shade val="50000"/>
-            </a:schemeClr>
-          </a:lnRef>
-          <a:fillRef idx="1">
-            <a:schemeClr val="accent1"/>
-          </a:fillRef>
-          <a:effectRef idx="0">
-            <a:schemeClr val="accent1"/>
-          </a:effectRef>
-          <a:fontRef idx="minor">
-            <a:schemeClr val="lt1"/>
-          </a:fontRef>
-        </p:style>
-        <p:txBody>
-          <a:bodyPr wrap="square" lIns="76200" tIns="38100" rIns="76200" bIns="38100" rtlCol="0" anchor="ctr">
-            <a:noAutofit/>
-          </a:bodyPr>
-          <a:lstStyle/>
-          <a:p>
-            <a:pPr algn="ctr"/>
-            <a:r>
-              <a:rPr lang="es-ES" sz="900" i="1">
-                <a:solidFill>
-                  <a:srgbClr val="666666"/>
-                </a:solidFill>
-                <a:latin typeface="Arial" panose="020B0604020202020204" pitchFamily="34" charset="0"/>
-              </a:rPr>
-              <a:t>CAPTURA PENDIENTE</a:t>
-            </a:r>
-          </a:p>
-          <a:p>
-            <a:pPr algn="ctr"/>
-            <a:r>
-              <a:rPr lang="es-ES" sz="900" i="1">
-                <a:solidFill>
-                  <a:srgbClr val="666666"/>
-                </a:solidFill>
-                <a:latin typeface="Arial" panose="020B0604020202020204" pitchFamily="34" charset="0"/>
-              </a:rPr>
-              <a:t>Respuesta del servicio</a:t>
-            </a:r>
-            <a:endParaRPr lang="en-US" sz="900" i="1">
-              <a:solidFill>
-                <a:srgbClr val="666666"/>
-              </a:solidFill>
-              <a:latin typeface="Arial" panose="020B0604020202020204" pitchFamily="34" charset="0"/>
-            </a:endParaRPr>
-          </a:p>
-        </p:txBody>
-      </p:sp>
-      <p:sp>
-        <p:nvSpPr>
-          <p:cNvPr id="3" name="CAPTURA PENDIENTE - Prueba de conversión de temperatura">
-            <a:extLst>
-              <a:ext uri="{FF2B5EF4-FFF2-40B4-BE49-F238E27FC236}">
-                <a16:creationId xmlns:a16="http://schemas.microsoft.com/office/drawing/2014/main" id="{DEA656A8-E519-47C1-AE44-5E7BD4AF055A}"/>
-              </a:ext>
-            </a:extLst>
-          </p:cNvPr>
-          <p:cNvSpPr/>
+      </p:pic>
+      <p:pic>
+        <p:nvPicPr>
+          <p:cNvPr id="192" name="image65.png"/>
+          <p:cNvPicPr/>
           <p:nvPr/>
-        </p:nvSpPr>
+        </p:nvPicPr>
+        <p:blipFill>
+          <a:blip r:embed="rId4"/>
+          <a:srcRect/>
+          <a:stretch>
+            <a:fillRect/>
+          </a:stretch>
+        </p:blipFill>
         <p:spPr>
           <a:xfrm>
             <a:off x="2961150" y="4415104"/>
@@ -39844,80 +37667,26 @@
           <a:prstGeom prst="rect">
             <a:avLst/>
           </a:prstGeom>
-          <a:solidFill>
-            <a:srgbClr val="FFFFFF"/>
-          </a:solidFill>
-          <a:ln w="15875">
+          <a:ln w="12700">
             <a:solidFill>
-              <a:srgbClr val="D9D9D9"/>
+              <a:srgbClr val="CCCCCC"/>
             </a:solidFill>
           </a:ln>
         </p:spPr>
-        <p:style>
-          <a:lnRef idx="2">
-            <a:schemeClr val="accent1">
-              <a:shade val="50000"/>
-            </a:schemeClr>
-          </a:lnRef>
-          <a:fillRef idx="1">
-            <a:schemeClr val="accent1"/>
-          </a:fillRef>
-          <a:effectRef idx="0">
-            <a:schemeClr val="accent1"/>
-          </a:effectRef>
-          <a:fontRef idx="minor">
-            <a:schemeClr val="lt1"/>
-          </a:fontRef>
-        </p:style>
-        <p:txBody>
-          <a:bodyPr wrap="square" lIns="76200" tIns="38100" rIns="76200" bIns="38100" rtlCol="0" anchor="ctr">
-            <a:noAutofit/>
-          </a:bodyPr>
-          <a:lstStyle/>
-          <a:p>
-            <a:pPr algn="ctr"/>
-            <a:r>
-              <a:rPr lang="es-ES" sz="900" i="1">
-                <a:solidFill>
-                  <a:srgbClr val="666666"/>
-                </a:solidFill>
-                <a:latin typeface="Arial" panose="020B0604020202020204" pitchFamily="34" charset="0"/>
-              </a:rPr>
-              <a:t>CAPTURA PENDIENTE</a:t>
-            </a:r>
-          </a:p>
-          <a:p>
-            <a:pPr algn="ctr"/>
-            <a:r>
-              <a:rPr lang="es-ES" sz="900" i="1">
-                <a:solidFill>
-                  <a:srgbClr val="666666"/>
-                </a:solidFill>
-                <a:latin typeface="Arial" panose="020B0604020202020204" pitchFamily="34" charset="0"/>
-              </a:rPr>
-              <a:t>Prueba de conversión de temperatura</a:t>
-            </a:r>
-            <a:endParaRPr lang="en-US" sz="900" i="1">
-              <a:solidFill>
-                <a:srgbClr val="666666"/>
-              </a:solidFill>
-              <a:latin typeface="Arial" panose="020B0604020202020204" pitchFamily="34" charset="0"/>
-            </a:endParaRPr>
-          </a:p>
-        </p:txBody>
-      </p:sp>
-      <p:sp>
-        <p:nvSpPr>
-          <p:cNvPr id="4" name="CAPTURA PENDIENTE - Prueba de conversión de masa">
-            <a:extLst>
-              <a:ext uri="{FF2B5EF4-FFF2-40B4-BE49-F238E27FC236}">
-                <a16:creationId xmlns:a16="http://schemas.microsoft.com/office/drawing/2014/main" id="{C2E3AF7B-1C5B-485E-8F00-68AB1DFA319F}"/>
-              </a:ext>
-            </a:extLst>
-          </p:cNvPr>
-          <p:cNvSpPr/>
+      </p:pic>
+      <p:pic>
+        <p:nvPicPr>
+          <p:cNvPr id="193" name="image66.png"/>
+          <p:cNvPicPr/>
           <p:nvPr/>
-        </p:nvSpPr>
+        </p:nvPicPr>
+        <p:blipFill>
+          <a:blip r:embed="rId5"/>
+          <a:srcRect/>
+          <a:stretch>
+            <a:fillRect/>
+          </a:stretch>
+        </p:blipFill>
         <p:spPr>
           <a:xfrm>
             <a:off x="330934" y="4415104"/>
@@ -39926,80 +37695,26 @@
           <a:prstGeom prst="rect">
             <a:avLst/>
           </a:prstGeom>
-          <a:solidFill>
-            <a:srgbClr val="FFFFFF"/>
-          </a:solidFill>
-          <a:ln w="15875">
+          <a:ln w="12700">
             <a:solidFill>
-              <a:srgbClr val="D9D9D9"/>
+              <a:srgbClr val="CCCCCC"/>
             </a:solidFill>
           </a:ln>
         </p:spPr>
-        <p:style>
-          <a:lnRef idx="2">
-            <a:schemeClr val="accent1">
-              <a:shade val="50000"/>
-            </a:schemeClr>
-          </a:lnRef>
-          <a:fillRef idx="1">
-            <a:schemeClr val="accent1"/>
-          </a:fillRef>
-          <a:effectRef idx="0">
-            <a:schemeClr val="accent1"/>
-          </a:effectRef>
-          <a:fontRef idx="minor">
-            <a:schemeClr val="lt1"/>
-          </a:fontRef>
-        </p:style>
-        <p:txBody>
-          <a:bodyPr wrap="square" lIns="76200" tIns="38100" rIns="76200" bIns="38100" rtlCol="0" anchor="ctr">
-            <a:noAutofit/>
-          </a:bodyPr>
-          <a:lstStyle/>
-          <a:p>
-            <a:pPr algn="ctr"/>
-            <a:r>
-              <a:rPr lang="es-ES" sz="900" i="1">
-                <a:solidFill>
-                  <a:srgbClr val="666666"/>
-                </a:solidFill>
-                <a:latin typeface="Arial" panose="020B0604020202020204" pitchFamily="34" charset="0"/>
-              </a:rPr>
-              <a:t>CAPTURA PENDIENTE</a:t>
-            </a:r>
-          </a:p>
-          <a:p>
-            <a:pPr algn="ctr"/>
-            <a:r>
-              <a:rPr lang="es-ES" sz="900" i="1">
-                <a:solidFill>
-                  <a:srgbClr val="666666"/>
-                </a:solidFill>
-                <a:latin typeface="Arial" panose="020B0604020202020204" pitchFamily="34" charset="0"/>
-              </a:rPr>
-              <a:t>Prueba de conversión de masa</a:t>
-            </a:r>
-            <a:endParaRPr lang="en-US" sz="900" i="1">
-              <a:solidFill>
-                <a:srgbClr val="666666"/>
-              </a:solidFill>
-              <a:latin typeface="Arial" panose="020B0604020202020204" pitchFamily="34" charset="0"/>
-            </a:endParaRPr>
-          </a:p>
-        </p:txBody>
-      </p:sp>
-      <p:sp>
-        <p:nvSpPr>
-          <p:cNvPr id="5" name="CAPTURA PENDIENTE - Prueba de conversión de longitud">
-            <a:extLst>
-              <a:ext uri="{FF2B5EF4-FFF2-40B4-BE49-F238E27FC236}">
-                <a16:creationId xmlns:a16="http://schemas.microsoft.com/office/drawing/2014/main" id="{C9C3B946-C4DF-42E1-81A6-50079FD40A92}"/>
-              </a:ext>
-            </a:extLst>
-          </p:cNvPr>
-          <p:cNvSpPr/>
+      </p:pic>
+      <p:pic>
+        <p:nvPicPr>
+          <p:cNvPr id="194" name="image67.png"/>
+          <p:cNvPicPr/>
           <p:nvPr/>
-        </p:nvSpPr>
+        </p:nvPicPr>
+        <p:blipFill>
+          <a:blip r:embed="rId6"/>
+          <a:srcRect/>
+          <a:stretch>
+            <a:fillRect/>
+          </a:stretch>
+        </p:blipFill>
         <p:spPr>
           <a:xfrm>
             <a:off x="4671319" y="1994161"/>
@@ -40008,80 +37723,26 @@
           <a:prstGeom prst="rect">
             <a:avLst/>
           </a:prstGeom>
-          <a:solidFill>
-            <a:srgbClr val="FFFFFF"/>
-          </a:solidFill>
-          <a:ln w="15875">
+          <a:ln w="12700">
             <a:solidFill>
-              <a:srgbClr val="D9D9D9"/>
+              <a:srgbClr val="CCCCCC"/>
             </a:solidFill>
           </a:ln>
         </p:spPr>
-        <p:style>
-          <a:lnRef idx="2">
-            <a:schemeClr val="accent1">
-              <a:shade val="50000"/>
-            </a:schemeClr>
-          </a:lnRef>
-          <a:fillRef idx="1">
-            <a:schemeClr val="accent1"/>
-          </a:fillRef>
-          <a:effectRef idx="0">
-            <a:schemeClr val="accent1"/>
-          </a:effectRef>
-          <a:fontRef idx="minor">
-            <a:schemeClr val="lt1"/>
-          </a:fontRef>
-        </p:style>
-        <p:txBody>
-          <a:bodyPr wrap="square" lIns="76200" tIns="38100" rIns="76200" bIns="38100" rtlCol="0" anchor="ctr">
-            <a:noAutofit/>
-          </a:bodyPr>
-          <a:lstStyle/>
-          <a:p>
-            <a:pPr algn="ctr"/>
-            <a:r>
-              <a:rPr lang="es-ES" sz="900" i="1">
-                <a:solidFill>
-                  <a:srgbClr val="666666"/>
-                </a:solidFill>
-                <a:latin typeface="Arial" panose="020B0604020202020204" pitchFamily="34" charset="0"/>
-              </a:rPr>
-              <a:t>CAPTURA PENDIENTE</a:t>
-            </a:r>
-          </a:p>
-          <a:p>
-            <a:pPr algn="ctr"/>
-            <a:r>
-              <a:rPr lang="es-ES" sz="900" i="1">
-                <a:solidFill>
-                  <a:srgbClr val="666666"/>
-                </a:solidFill>
-                <a:latin typeface="Arial" panose="020B0604020202020204" pitchFamily="34" charset="0"/>
-              </a:rPr>
-              <a:t>Prueba de conversión de longitud</a:t>
-            </a:r>
-            <a:endParaRPr lang="en-US" sz="900" i="1">
-              <a:solidFill>
-                <a:srgbClr val="666666"/>
-              </a:solidFill>
-              <a:latin typeface="Arial" panose="020B0604020202020204" pitchFamily="34" charset="0"/>
-            </a:endParaRPr>
-          </a:p>
-        </p:txBody>
-      </p:sp>
-      <p:sp>
-        <p:nvSpPr>
-          <p:cNvPr id="6" name="CAPTURA PENDIENTE - Prueba de autenticación">
-            <a:extLst>
-              <a:ext uri="{FF2B5EF4-FFF2-40B4-BE49-F238E27FC236}">
-                <a16:creationId xmlns:a16="http://schemas.microsoft.com/office/drawing/2014/main" id="{D9C4CD0A-85E6-4476-8C1E-18E66A405171}"/>
-              </a:ext>
-            </a:extLst>
-          </p:cNvPr>
-          <p:cNvSpPr/>
+      </p:pic>
+      <p:pic>
+        <p:nvPicPr>
+          <p:cNvPr id="195" name="image64.png"/>
+          <p:cNvPicPr/>
           <p:nvPr/>
-        </p:nvSpPr>
+        </p:nvPicPr>
+        <p:blipFill>
+          <a:blip r:embed="rId7"/>
+          <a:srcRect/>
+          <a:stretch>
+            <a:fillRect/>
+          </a:stretch>
+        </p:blipFill>
         <p:spPr>
           <a:xfrm>
             <a:off x="679863" y="2724790"/>
@@ -40090,68 +37751,13 @@
           <a:prstGeom prst="rect">
             <a:avLst/>
           </a:prstGeom>
-          <a:solidFill>
-            <a:srgbClr val="FFFFFF"/>
-          </a:solidFill>
-          <a:ln w="15875">
+          <a:ln w="12700">
             <a:solidFill>
-              <a:srgbClr val="D9D9D9"/>
+              <a:srgbClr val="CCCCCC"/>
             </a:solidFill>
           </a:ln>
         </p:spPr>
-        <p:style>
-          <a:lnRef idx="2">
-            <a:schemeClr val="accent1">
-              <a:shade val="50000"/>
-            </a:schemeClr>
-          </a:lnRef>
-          <a:fillRef idx="1">
-            <a:schemeClr val="accent1"/>
-          </a:fillRef>
-          <a:effectRef idx="0">
-            <a:schemeClr val="accent1"/>
-          </a:effectRef>
-          <a:fontRef idx="minor">
-            <a:schemeClr val="lt1"/>
-          </a:fontRef>
-        </p:style>
-        <p:txBody>
-          <a:bodyPr wrap="square" lIns="76200" tIns="38100" rIns="76200" bIns="38100" rtlCol="0" anchor="ctr">
-            <a:noAutofit/>
-          </a:bodyPr>
-          <a:lstStyle/>
-          <a:p>
-            <a:pPr algn="ctr"/>
-            <a:r>
-              <a:rPr lang="es-ES" sz="900" i="1">
-                <a:solidFill>
-                  <a:srgbClr val="666666"/>
-                </a:solidFill>
-                <a:latin typeface="Arial" panose="020B0604020202020204" pitchFamily="34" charset="0"/>
-              </a:rPr>
-              <a:t>CAPTURA PENDIENTE</a:t>
-            </a:r>
-          </a:p>
-          <a:p>
-            <a:pPr algn="ctr"/>
-            <a:r>
-              <a:rPr lang="es-ES" sz="900" i="1">
-                <a:solidFill>
-                  <a:srgbClr val="666666"/>
-                </a:solidFill>
-                <a:latin typeface="Arial" panose="020B0604020202020204" pitchFamily="34" charset="0"/>
-              </a:rPr>
-              <a:t>Prueba de autenticación</a:t>
-            </a:r>
-            <a:endParaRPr lang="en-US" sz="900" i="1">
-              <a:solidFill>
-                <a:srgbClr val="666666"/>
-              </a:solidFill>
-              <a:latin typeface="Arial" panose="020B0604020202020204" pitchFamily="34" charset="0"/>
-            </a:endParaRPr>
-          </a:p>
-        </p:txBody>
-      </p:sp>
+      </p:pic>
     </p:spTree>
   </p:cSld>
   <p:clrMapOvr>
@@ -40838,18 +38444,19 @@
           </a:p>
         </p:txBody>
       </p:sp>
-      <p:sp>
-        <p:nvSpPr>
-          <p:cNvPr id="2" name="CAPTURA PENDIENTE - Configuración del cliente de consola">
-            <a:extLst>
-              <a:ext uri="{FF2B5EF4-FFF2-40B4-BE49-F238E27FC236}">
-                <a16:creationId xmlns:a16="http://schemas.microsoft.com/office/drawing/2014/main" id="{3A7959C0-C4A0-43B5-A418-6987B537CAD0}"/>
-              </a:ext>
-            </a:extLst>
-          </p:cNvPr>
-          <p:cNvSpPr/>
+      <p:pic>
+        <p:nvPicPr>
+          <p:cNvPr id="223" name="image68.png"/>
+          <p:cNvPicPr/>
           <p:nvPr/>
-        </p:nvSpPr>
+        </p:nvPicPr>
+        <p:blipFill>
+          <a:blip r:embed="rId3"/>
+          <a:srcRect/>
+          <a:stretch>
+            <a:fillRect/>
+          </a:stretch>
+        </p:blipFill>
         <p:spPr>
           <a:xfrm>
             <a:off x="4740234" y="3657435"/>
@@ -40858,80 +38465,26 @@
           <a:prstGeom prst="rect">
             <a:avLst/>
           </a:prstGeom>
-          <a:solidFill>
-            <a:srgbClr val="FFFFFF"/>
-          </a:solidFill>
-          <a:ln w="15875">
+          <a:ln w="12700">
             <a:solidFill>
-              <a:srgbClr val="D9D9D9"/>
+              <a:srgbClr val="CCCCCC"/>
             </a:solidFill>
           </a:ln>
         </p:spPr>
-        <p:style>
-          <a:lnRef idx="2">
-            <a:schemeClr val="accent1">
-              <a:shade val="50000"/>
-            </a:schemeClr>
-          </a:lnRef>
-          <a:fillRef idx="1">
-            <a:schemeClr val="accent1"/>
-          </a:fillRef>
-          <a:effectRef idx="0">
-            <a:schemeClr val="accent1"/>
-          </a:effectRef>
-          <a:fontRef idx="minor">
-            <a:schemeClr val="lt1"/>
-          </a:fontRef>
-        </p:style>
-        <p:txBody>
-          <a:bodyPr wrap="square" lIns="76200" tIns="38100" rIns="76200" bIns="38100" rtlCol="0" anchor="ctr">
-            <a:noAutofit/>
-          </a:bodyPr>
-          <a:lstStyle/>
-          <a:p>
-            <a:pPr algn="ctr"/>
-            <a:r>
-              <a:rPr lang="es-ES" sz="900" i="1">
-                <a:solidFill>
-                  <a:srgbClr val="666666"/>
-                </a:solidFill>
-                <a:latin typeface="Arial" panose="020B0604020202020204" pitchFamily="34" charset="0"/>
-              </a:rPr>
-              <a:t>CAPTURA PENDIENTE</a:t>
-            </a:r>
-          </a:p>
-          <a:p>
-            <a:pPr algn="ctr"/>
-            <a:r>
-              <a:rPr lang="es-ES" sz="900" i="1">
-                <a:solidFill>
-                  <a:srgbClr val="666666"/>
-                </a:solidFill>
-                <a:latin typeface="Arial" panose="020B0604020202020204" pitchFamily="34" charset="0"/>
-              </a:rPr>
-              <a:t>Configuración del cliente de consola</a:t>
-            </a:r>
-            <a:endParaRPr lang="en-US" sz="900" i="1">
-              <a:solidFill>
-                <a:srgbClr val="666666"/>
-              </a:solidFill>
-              <a:latin typeface="Arial" panose="020B0604020202020204" pitchFamily="34" charset="0"/>
-            </a:endParaRPr>
-          </a:p>
-        </p:txBody>
-      </p:sp>
-      <p:sp>
-        <p:nvSpPr>
-          <p:cNvPr id="3" name="CAPTURA PENDIENTE - Creación del proyecto .NET / C# Maven">
-            <a:extLst>
-              <a:ext uri="{FF2B5EF4-FFF2-40B4-BE49-F238E27FC236}">
-                <a16:creationId xmlns:a16="http://schemas.microsoft.com/office/drawing/2014/main" id="{6398EAC1-FA1A-438E-84B6-8806E14BAE12}"/>
-              </a:ext>
-            </a:extLst>
-          </p:cNvPr>
-          <p:cNvSpPr/>
+      </p:pic>
+      <p:pic>
+        <p:nvPicPr>
+          <p:cNvPr id="224" name="image69.png"/>
+          <p:cNvPicPr/>
           <p:nvPr/>
-        </p:nvSpPr>
+        </p:nvPicPr>
+        <p:blipFill>
+          <a:blip r:embed="rId4"/>
+          <a:srcRect/>
+          <a:stretch>
+            <a:fillRect/>
+          </a:stretch>
+        </p:blipFill>
         <p:spPr>
           <a:xfrm>
             <a:off x="466506" y="3674580"/>
@@ -40940,68 +38493,13 @@
           <a:prstGeom prst="rect">
             <a:avLst/>
           </a:prstGeom>
-          <a:solidFill>
-            <a:srgbClr val="FFFFFF"/>
-          </a:solidFill>
-          <a:ln w="15875">
+          <a:ln w="12700">
             <a:solidFill>
-              <a:srgbClr val="D9D9D9"/>
+              <a:srgbClr val="CCCCCC"/>
             </a:solidFill>
           </a:ln>
         </p:spPr>
-        <p:style>
-          <a:lnRef idx="2">
-            <a:schemeClr val="accent1">
-              <a:shade val="50000"/>
-            </a:schemeClr>
-          </a:lnRef>
-          <a:fillRef idx="1">
-            <a:schemeClr val="accent1"/>
-          </a:fillRef>
-          <a:effectRef idx="0">
-            <a:schemeClr val="accent1"/>
-          </a:effectRef>
-          <a:fontRef idx="minor">
-            <a:schemeClr val="lt1"/>
-          </a:fontRef>
-        </p:style>
-        <p:txBody>
-          <a:bodyPr wrap="square" lIns="76200" tIns="38100" rIns="76200" bIns="38100" rtlCol="0" anchor="ctr">
-            <a:noAutofit/>
-          </a:bodyPr>
-          <a:lstStyle/>
-          <a:p>
-            <a:pPr algn="ctr"/>
-            <a:r>
-              <a:rPr lang="es-ES" sz="900" i="1">
-                <a:solidFill>
-                  <a:srgbClr val="666666"/>
-                </a:solidFill>
-                <a:latin typeface="Arial" panose="020B0604020202020204" pitchFamily="34" charset="0"/>
-              </a:rPr>
-              <a:t>CAPTURA PENDIENTE</a:t>
-            </a:r>
-          </a:p>
-          <a:p>
-            <a:pPr algn="ctr"/>
-            <a:r>
-              <a:rPr lang="es-ES" sz="900" i="1">
-                <a:solidFill>
-                  <a:srgbClr val="666666"/>
-                </a:solidFill>
-                <a:latin typeface="Arial" panose="020B0604020202020204" pitchFamily="34" charset="0"/>
-              </a:rPr>
-              <a:t>Creación del proyecto .NET / C# Maven</a:t>
-            </a:r>
-            <a:endParaRPr lang="en-US" sz="900" i="1">
-              <a:solidFill>
-                <a:srgbClr val="666666"/>
-              </a:solidFill>
-              <a:latin typeface="Arial" panose="020B0604020202020204" pitchFamily="34" charset="0"/>
-            </a:endParaRPr>
-          </a:p>
-        </p:txBody>
-      </p:sp>
+      </p:pic>
     </p:spTree>
   </p:cSld>
   <p:clrMapOvr>

</xml_diff>

<commit_message>
docs(dotnet): corregir stack MAUI y servicios
</commit_message>
<xml_diff>
--- a/TI.1.2. PAO202651_SOAP_DOTNET_SINBDD_NRC36884_GR09/05. DOCUMENTACION/CONVUNI_SOAP_DOTNET_GR09.pptx
+++ b/TI.1.2. PAO202651_SOAP_DOTNET_SINBDD_NRC36884_GR09/05. DOCUMENTACION/CONVUNI_SOAP_DOTNET_GR09.pptx
@@ -21374,7 +21374,7 @@
                 <a:cs typeface="Cambria"/>
                 <a:sym typeface="Cambria"/>
               </a:rPr>
-              <a:t>1.4 CREACIÓN DEL PROYECTO – CLIENTE ESCRITORIO</a:t>
+              <a:t>1.4 CREACIÓN DEL CLIENTE DE ESCRITORIO Cliente C#/.NET 10 para Windows, implementado con WPF. Consume SOAP/XML por HTTP mediante MVC.</a:t>
             </a:r>
           </a:p>
           <a:p>
@@ -21419,7 +21419,7 @@
                 <a:cs typeface="Cambria"/>
                 <a:sym typeface="Cambria"/>
               </a:rPr>
-              <a:t>Crea la aplicación .NET / C# de escritorio con Maven. La interfaz Swing consume los mismos endpoints SOAP y sigue el patrón Modelo-Vista-Controlador.</a:t>
+              <a:t/>
             </a:r>
             <a:endParaRPr lang="es-MX" dirty="0">
               <a:latin typeface="Cambria"/>
@@ -22049,7 +22049,7 @@
                 <a:cs typeface="Cambria"/>
                 <a:sym typeface="Cambria"/>
               </a:rPr>
-              <a:t>El cliente Swing organiza la interfaz, el estado de conversión y el consumo SOAP con el patrón MVC.</a:t>
+              <a:t/>
             </a:r>
             <a:endParaRPr lang="es-MX" sz="1800" dirty="0">
               <a:latin typeface="Cambria"/>
@@ -22862,7 +22862,7 @@
                 <a:latin typeface="Calibri" panose="020F0502020204030204" pitchFamily="34" charset="0"/>
                 <a:ea typeface="Calibri" panose="020F0502020204030204" pitchFamily="34" charset="0"/>
               </a:rPr>
-              <a:t>La vista Swing contiene las ventanas de autenticación y conversión. Los controles permiten seleccionar magnitud y unidades, ingresar el valor y consultar el resultado.</a:t>
+              <a:t/>
             </a:r>
             <a:endParaRPr sz="1800" dirty="0">
               <a:latin typeface="Cambria"/>
@@ -24752,7 +24752,7 @@
                 <a:cs typeface="Cambria"/>
                 <a:sym typeface="Cambria"/>
               </a:rPr>
-              <a:t>1.5 CREACIÓN DEL PROYECTO – CLIENTE WEB</a:t>
+              <a:t>1.5 CREACIÓN DEL CLIENTE WEB Cliente web C#/.NET 10 con ASP.NET Core. Consume los endpoints SOAP por HTTP para autenticación y conversión.</a:t>
             </a:r>
           </a:p>
           <a:p>
@@ -24811,7 +24811,7 @@
                 <a:cs typeface="Cambria"/>
                 <a:sym typeface="Cambria"/>
               </a:rPr>
-              <a:t>El cliente web se ejecuta con Jetty 11 embebido en el puerto 8081. Las vistas HTML/JSP presentan las pantallas; LoginServlet y ConversionServlet gestionan la sesión y las solicitudes SOAP.</a:t>
+              <a:t/>
             </a:r>
             <a:endParaRPr sz="2000" dirty="0">
               <a:solidFill>
@@ -25825,7 +25825,7 @@
                   <a:schemeClr val="lt1"/>
                 </a:solidFill>
               </a:rPr>
-              <a:t>CREACIÓN DEL SERVIDOR SOAP EN JAVA</a:t>
+              <a:t>CREACIÓN DEL SERVIDOR SOAP EN .NET</a:t>
             </a:r>
           </a:p>
           <a:p>
@@ -29174,7 +29174,7 @@
                 <a:cs typeface="Cambria"/>
                 <a:sym typeface="Cambria"/>
               </a:rPr>
-              <a:t>1.6 CLIENTE MÓVIL</a:t>
+              <a:t>1.6 CLIENTE MÓVIL Cliente Android .NET MAUI 10, C# 14, XAML, HttpClient, net10.0-android y API mínima 21. Envía SOAP 1.1/XML al servidor ASP.NET Core. Hotspot: 192.168.137.1:8733; emulador: 10.0.2.2:8733.</a:t>
             </a:r>
             <a:endParaRPr sz="1800" b="0" i="0" u="none" strike="noStrike" cap="none">
               <a:solidFill>
@@ -29237,7 +29237,7 @@
                 <a:cs typeface="Cambria"/>
                 <a:sym typeface="Cambria"/>
               </a:rPr>
-              <a:t>Crea una aplicación Android con .NET / C# y una actividad vacía. Agrega HttpClient / CoreWCF y configura el acceso al servicio SOAP en localhost:8080.</a:t>
+              <a:t/>
             </a:r>
           </a:p>
           <a:p>
@@ -29261,7 +29261,7 @@
                 <a:cs typeface="Cambria"/>
                 <a:sym typeface="Cambria"/>
               </a:rPr>
-              <a:t>En emulador o dispositivo físico, usa una dirección de host accesible desde Android.</a:t>
+              <a:t/>
             </a:r>
             <a:endParaRPr sz="1564" b="1">
               <a:latin typeface="Cambria"/>
@@ -29946,7 +29946,7 @@
                 <a:cs typeface="Cambria"/>
                 <a:sym typeface="Cambria"/>
               </a:rPr>
-              <a:t>Estructura del Proyecto (MVC)</a:t>
+              <a:t>Estructura del proyecto MAUI: páginas XAML, lógica C# y SoapClient.cs. El flujo móvil implementa autenticación y conversión.</a:t>
             </a:r>
           </a:p>
           <a:p>
@@ -29970,7 +29970,7 @@
                 <a:cs typeface="Cambria"/>
                 <a:sym typeface="Cambria"/>
               </a:rPr>
-              <a:t>La aplicación separa actividades de interfaz, controladores, modelos y cliente SOAP. El patrón MVC organiza el inicio de sesión y el flujo de conversión.</a:t>
+              <a:t/>
             </a:r>
             <a:endParaRPr lang="es-EC" sz="1564" dirty="0">
               <a:latin typeface="Cambria"/>
@@ -30599,7 +30599,7 @@
                 <a:cs typeface="Cambria"/>
                 <a:sym typeface="Cambria"/>
               </a:rPr>
-              <a:t>Modelo: SoapClient.java</a:t>
+              <a:t>SoapClient.cs usa HttpClient y XML para enviar solicitudes SOAP 1.1 y procesar respuestas.</a:t>
             </a:r>
           </a:p>
           <a:p>
@@ -30623,7 +30623,7 @@
                 <a:cs typeface="Cambria"/>
                 <a:sym typeface="Cambria"/>
               </a:rPr>
-              <a:t>Usa HttpClient / CoreWCF para construir solicitudes SOAP y procesar respuestas del servicio.</a:t>
+              <a:t/>
             </a:r>
             <a:endParaRPr sz="1564" b="1" dirty="0">
               <a:latin typeface="Cambria"/>
@@ -30683,7 +30683,7 @@
                 <a:cs typeface="Cambria"/>
                 <a:sym typeface="Cambria"/>
               </a:rPr>
-              <a:t>Controlador: ConversionController.java</a:t>
+              <a:t>Controlador C# coordina unidades, valida datos y solicita la conversión SOAP.</a:t>
             </a:r>
           </a:p>
           <a:p>
@@ -31364,7 +31364,7 @@
                 <a:cs typeface="Cambria"/>
                 <a:sym typeface="Cambria"/>
               </a:rPr>
-              <a:t>Vista: LoginActivity.java</a:t>
+              <a:t>LoginPage solicita MONSTER / MONSTER9 y continúa al conversor tras autenticarse.</a:t>
             </a:r>
           </a:p>
           <a:p>
@@ -31448,7 +31448,7 @@
                 <a:cs typeface="Cambria"/>
                 <a:sym typeface="Cambria"/>
               </a:rPr>
-              <a:t>Vista: ConversionActivity.java</a:t>
+              <a:t>MainPage permite elegir magnitud/unidades, ingresar un valor y consultar el resultado SOAP.</a:t>
             </a:r>
           </a:p>
           <a:p>
@@ -32130,7 +32130,7 @@
                 <a:cs typeface="Cambria"/>
                 <a:sym typeface="Cambria"/>
               </a:rPr>
-              <a:t>Ejecuta primero el servidor SOAP. Luego inicia la aplicación en un emulador o dispositivo Android y verifica el acceso a la dirección del host y al puerto 8080.</a:t>
+              <a:t/>
             </a:r>
             <a:endParaRPr dirty="0">
               <a:latin typeface="Cambria"/>
@@ -32946,7 +32946,7 @@
                 <a:cs typeface="Cambria"/>
                 <a:sym typeface="Cambria"/>
               </a:rPr>
-              <a:t>1.1 OBJETIVO</a:t>
+              <a:t>1.1 OBJETIVO Sistema .NET 10/C# 14: servidor ASP.NET Core 10/Kestrel con SOAP 1.1/XML en TCP 8733; clientes .NET de consola, WPF, web y Android MAUI. El móvil usa XAML y HttpClient, sin campo de URL. Login MONSTER/MONSTER9; datos en memoria (SINBDD).</a:t>
             </a:r>
           </a:p>
           <a:p>
@@ -32993,7 +32993,7 @@
                 <a:cs typeface="Cambria"/>
                 <a:sym typeface="Cambria"/>
               </a:rPr>
-              <a:t>Documentar la configuración, arquitectura, ejecución y validación del conversor de unidades. El sistema ofrece clientes de consola, escritorio, web y móvil conectados a un servicio .NET / C# de tipo </a:t>
+              <a:t/>
             </a:r>
           </a:p>
           <a:p>
@@ -34273,7 +34273,7 @@
                 <a:cs typeface="Cambria"/>
                 <a:sym typeface="Cambria"/>
               </a:rPr>
-              <a:t>1.2 CREACIÓN DEL SERVIDOR SOAP</a:t>
+              <a:t>1.2 CREACIÓN DEL SERVIDOR SOAP Servidor C# 14/.NET 10 con ASP.NET Core 10 y Kestrel. ManejadorSOAP procesa SOAP 1.1/XML y genera WSDL. Escucha en TCP 8733. Compila con dotnet build.</a:t>
             </a:r>
           </a:p>
           <a:p>
@@ -34318,7 +34318,7 @@
                 <a:cs typeface="Cambria"/>
                 <a:sym typeface="Cambria"/>
               </a:rPr>
-              <a:t>.NET 8.0 SDK, Jakarta XML Web Services y Metro. Program.cs (CoreWCF / Kestrel) publica ambos endpoints en localhost:8080.</a:t>
+              <a:t/>
             </a:r>
           </a:p>
           <a:p>
@@ -35753,7 +35753,7 @@
                 <a:cs typeface="Cambria"/>
                 <a:sym typeface="Cambria"/>
               </a:rPr>
-              <a:t>ARQUITECTURA DEL SERVIDOR</a:t>
+              <a:t>ARQUITECTURA DEL SERVIDOR ASP.NET Core inicia Kestrel y enruta las solicitudes a ManejadorSOAP, que procesa SOAP 1.1 y delega autenticación y conversiones. Escucha en el puerto 8733; los datos permanecen en memoria.</a:t>
             </a:r>
           </a:p>
           <a:p>
@@ -35798,7 +35798,7 @@
                 <a:cs typeface="Cambria"/>
                 <a:sym typeface="Cambria"/>
               </a:rPr>
-              <a:t>La solución separa la publicación del servicio de la lógica de conversión. Publisher inicializa Metro; los endpoints SOAP delegan autenticación y conversiones en las clases de servicio.</a:t>
+              <a:t>La solución separa la publicación del servicio de la lógica de conversión. ASP.NET Core inicia Kestrel y enruta las solicitudes a ManejadorSOAP, que procesa SOAP 1.1 y delega autenticación y conversiones. Escucha en el puerto 8733.</a:t>
             </a:r>
           </a:p>
           <a:p>
@@ -36450,7 +36450,7 @@
                 <a:cs typeface="Cambria"/>
                 <a:sym typeface="Cambria"/>
               </a:rPr>
-              <a:t>PUBLICACIÓN DE ENDPOINTS</a:t>
+              <a:t>PUBLICACIÓN DE ENDPOINTS Program.cs configura Kestrel y publica ManejadorSOAP en las rutas de autenticación y conversión del puerto 8733. Mantén el servidor activo mientras se ejecutan los clientes .NET.</a:t>
             </a:r>
           </a:p>
           <a:p>
@@ -36493,7 +36493,7 @@
                 <a:cs typeface="Cambria"/>
                 <a:sym typeface="Cambria"/>
               </a:rPr>
-              <a:t>Program.cs (CoreWCF / Kestrel) inicia Metro en localhost:8080 y publica ServicioAutenticacion y ServicioConversion.</a:t>
+              <a:t>Program.cs configura Kestrel y publica ManejadorSOAP en las rutas de autenticación y conversión del puerto 8733.</a:t>
             </a:r>
           </a:p>
           <a:p>
@@ -37890,7 +37890,7 @@
                 <a:cs typeface="Cambria"/>
                 <a:sym typeface="Cambria"/>
               </a:rPr>
-              <a:t>1.3 CREACIÓN DEL CLIENTE CONSOLA</a:t>
+              <a:t>1.3 CREACIÓN DEL CLIENTE CONSOLA Cliente de consola C#/.NET 10. Consume SOAP 1.1/XML por HTTP y separa modelo, vista y controlador; inicia con autenticación.</a:t>
             </a:r>
           </a:p>
           <a:p>
@@ -37943,7 +37943,7 @@
                 <a:cs typeface="Cambria"/>
                 <a:sym typeface="Cambria"/>
               </a:rPr>
-              <a:t>Crea una aplicación .NET / C# con Maven en Visual Studio / VS Code. Configura el consumo de los endpoints SOAP y separa modelo, vista y controlador.</a:t>
+              <a:t/>
             </a:r>
           </a:p>
           <a:p>

</xml_diff>